<commit_message>
style: change presentation slides background theme to light cream and gold
</commit_message>
<xml_diff>
--- a/deliverables/INDUS_BRAIN_AI_Final_Pitch.pptx
+++ b/deliverables/INDUS_BRAIN_AI_Final_Pitch.pptx
@@ -3118,7 +3118,7 @@
             <a:avLst/>
           </a:prstGeom>
           <a:solidFill>
-            <a:srgbClr val="0B0F19"/>
+            <a:srgbClr val="FCFAF2"/>
           </a:solidFill>
           <a:ln>
             <a:noFill/>
@@ -3171,7 +3171,7 @@
             <a:pPr algn="ctr">
               <a:defRPr sz="5400" b="1">
                 <a:solidFill>
-                  <a:srgbClr val="38BDF8"/>
+                  <a:srgbClr val="927005"/>
                 </a:solidFill>
                 <a:latin typeface="Arial"/>
               </a:defRPr>
@@ -3187,7 +3187,7 @@
               </a:spcBef>
               <a:defRPr sz="2000" b="1">
                 <a:solidFill>
-                  <a:srgbClr val="34D399"/>
+                  <a:srgbClr val="1E293B"/>
                 </a:solidFill>
                 <a:latin typeface="Arial"/>
               </a:defRPr>
@@ -3203,7 +3203,7 @@
               </a:spcBef>
               <a:defRPr sz="1200">
                 <a:solidFill>
-                  <a:srgbClr val="94A3B8"/>
+                  <a:srgbClr val="64748B"/>
                 </a:solidFill>
                 <a:latin typeface="Arial"/>
               </a:defRPr>
@@ -3247,7 +3247,7 @@
             <a:avLst/>
           </a:prstGeom>
           <a:solidFill>
-            <a:srgbClr val="0B0F19"/>
+            <a:srgbClr val="FCFAF2"/>
           </a:solidFill>
           <a:ln>
             <a:noFill/>
@@ -3300,7 +3300,7 @@
             <a:pPr>
               <a:defRPr sz="2800" b="1">
                 <a:solidFill>
-                  <a:srgbClr val="38BDF8"/>
+                  <a:srgbClr val="927005"/>
                 </a:solidFill>
                 <a:latin typeface="Arial"/>
               </a:defRPr>
@@ -3336,7 +3336,7 @@
             <a:pPr>
               <a:defRPr sz="1400" b="1">
                 <a:solidFill>
-                  <a:srgbClr val="34D399"/>
+                  <a:srgbClr val="927005"/>
                 </a:solidFill>
               </a:defRPr>
             </a:pPr>
@@ -3346,7 +3346,7 @@
             <a:r>
               <a:rPr b="0">
                 <a:solidFill>
-                  <a:srgbClr val="E2E8F0"/>
+                  <a:srgbClr val="1E293B"/>
                 </a:solidFill>
               </a:rPr>
               <a:t>Traverses relational SQLite edges to predict downstream equipment risks based on trigger failures.</a:t>
@@ -3359,7 +3359,7 @@
               </a:spcBef>
               <a:defRPr sz="1400" b="1">
                 <a:solidFill>
-                  <a:srgbClr val="34D399"/>
+                  <a:srgbClr val="927005"/>
                 </a:solidFill>
               </a:defRPr>
             </a:pPr>
@@ -3369,7 +3369,7 @@
             <a:r>
               <a:rPr b="0">
                 <a:solidFill>
-                  <a:srgbClr val="E2E8F0"/>
+                  <a:srgbClr val="1E293B"/>
                 </a:solidFill>
               </a:rPr>
               <a:t>Outputs downtime risks (e.g. 82% elevated risk) and estimates financial impact ($45K loss).</a:t>
@@ -3382,7 +3382,7 @@
               </a:spcBef>
               <a:defRPr sz="1400" b="1">
                 <a:solidFill>
-                  <a:srgbClr val="34D399"/>
+                  <a:srgbClr val="927005"/>
                 </a:solidFill>
               </a:defRPr>
             </a:pPr>
@@ -3392,7 +3392,7 @@
             <a:r>
               <a:rPr b="0">
                 <a:solidFill>
-                  <a:srgbClr val="E2E8F0"/>
+                  <a:srgbClr val="1E293B"/>
                 </a:solidFill>
               </a:rPr>
               <a:t>Provides immediate corrective measures (e.g. 'Inspect suction valve VLV-204') to halt failure cascades.</a:t>
@@ -3457,7 +3457,7 @@
             <a:avLst/>
           </a:prstGeom>
           <a:solidFill>
-            <a:srgbClr val="0B0F19"/>
+            <a:srgbClr val="FCFAF2"/>
           </a:solidFill>
           <a:ln>
             <a:noFill/>
@@ -3510,7 +3510,7 @@
             <a:pPr>
               <a:defRPr sz="2800" b="1">
                 <a:solidFill>
-                  <a:srgbClr val="38BDF8"/>
+                  <a:srgbClr val="927005"/>
                 </a:solidFill>
                 <a:latin typeface="Arial"/>
               </a:defRPr>
@@ -3546,7 +3546,7 @@
             <a:pPr>
               <a:defRPr sz="1400" b="1">
                 <a:solidFill>
-                  <a:srgbClr val="38BDF8"/>
+                  <a:srgbClr val="927005"/>
                 </a:solidFill>
               </a:defRPr>
             </a:pPr>
@@ -3556,7 +3556,7 @@
             <a:r>
               <a:rPr b="0">
                 <a:solidFill>
-                  <a:srgbClr val="E2E8F0"/>
+                  <a:srgbClr val="1E293B"/>
                 </a:solidFill>
               </a:rPr>
               <a:t>100% verified citation accuracy across seed operating documents. Hallucinations eliminated.</a:t>
@@ -3569,7 +3569,7 @@
               </a:spcBef>
               <a:defRPr sz="1400" b="1">
                 <a:solidFill>
-                  <a:srgbClr val="38BDF8"/>
+                  <a:srgbClr val="927005"/>
                 </a:solidFill>
               </a:defRPr>
             </a:pPr>
@@ -3579,7 +3579,7 @@
             <a:r>
               <a:rPr b="0">
                 <a:solidFill>
-                  <a:srgbClr val="E2E8F0"/>
+                  <a:srgbClr val="1E293B"/>
                 </a:solidFill>
               </a:rPr>
               <a:t>Evaluated all safety rules across 35 ingested files, generating correct gap flags and remediation alerts.</a:t>
@@ -3592,7 +3592,7 @@
               </a:spcBef>
               <a:defRPr sz="1400" b="1">
                 <a:solidFill>
-                  <a:srgbClr val="38BDF8"/>
+                  <a:srgbClr val="927005"/>
                 </a:solidFill>
               </a:defRPr>
             </a:pPr>
@@ -3602,7 +3602,7 @@
             <a:r>
               <a:rPr b="0">
                 <a:solidFill>
-                  <a:srgbClr val="E2E8F0"/>
+                  <a:srgbClr val="1E293B"/>
                 </a:solidFill>
               </a:rPr>
               <a:t>Sub-second API response times and 60 FPS graph renders achieved via local SQLite indexes.</a:t>
@@ -3643,7 +3643,7 @@
                       <a:pPr algn="ctr">
                         <a:defRPr b="1" sz="1200">
                           <a:solidFill>
-                            <a:srgbClr val="38BDF8"/>
+                            <a:srgbClr val="1E293B"/>
                           </a:solidFill>
                         </a:defRPr>
                       </a:pPr>
@@ -3654,7 +3654,7 @@
                   </a:txBody>
                   <a:tcPr>
                     <a:solidFill>
-                      <a:srgbClr val="0B0F19"/>
+                      <a:srgbClr val="E8DFC5"/>
                     </a:solidFill>
                   </a:tcPr>
                 </a:tc>
@@ -3666,7 +3666,7 @@
                       <a:pPr algn="ctr">
                         <a:defRPr b="1" sz="1200">
                           <a:solidFill>
-                            <a:srgbClr val="38BDF8"/>
+                            <a:srgbClr val="1E293B"/>
                           </a:solidFill>
                         </a:defRPr>
                       </a:pPr>
@@ -3677,7 +3677,7 @@
                   </a:txBody>
                   <a:tcPr>
                     <a:solidFill>
-                      <a:srgbClr val="0B0F19"/>
+                      <a:srgbClr val="E8DFC5"/>
                     </a:solidFill>
                   </a:tcPr>
                 </a:tc>
@@ -3689,7 +3689,7 @@
                       <a:pPr algn="ctr">
                         <a:defRPr b="1" sz="1200">
                           <a:solidFill>
-                            <a:srgbClr val="38BDF8"/>
+                            <a:srgbClr val="1E293B"/>
                           </a:solidFill>
                         </a:defRPr>
                       </a:pPr>
@@ -3700,7 +3700,7 @@
                   </a:txBody>
                   <a:tcPr>
                     <a:solidFill>
-                      <a:srgbClr val="0B0F19"/>
+                      <a:srgbClr val="E8DFC5"/>
                     </a:solidFill>
                   </a:tcPr>
                 </a:tc>
@@ -3712,7 +3712,7 @@
                       <a:pPr algn="ctr">
                         <a:defRPr b="1" sz="1200">
                           <a:solidFill>
-                            <a:srgbClr val="38BDF8"/>
+                            <a:srgbClr val="1E293B"/>
                           </a:solidFill>
                         </a:defRPr>
                       </a:pPr>
@@ -3723,7 +3723,7 @@
                   </a:txBody>
                   <a:tcPr>
                     <a:solidFill>
-                      <a:srgbClr val="0B0F19"/>
+                      <a:srgbClr val="E8DFC5"/>
                     </a:solidFill>
                   </a:tcPr>
                 </a:tc>
@@ -3737,7 +3737,7 @@
                       <a:pPr algn="ctr">
                         <a:defRPr sz="1100">
                           <a:solidFill>
-                            <a:srgbClr val="E2E8F0"/>
+                            <a:srgbClr val="1E293B"/>
                           </a:solidFill>
                         </a:defRPr>
                       </a:pPr>
@@ -3748,7 +3748,7 @@
                   </a:txBody>
                   <a:tcPr>
                     <a:solidFill>
-                      <a:srgbClr val="0B0F19"/>
+                      <a:srgbClr val="FCFAF2"/>
                     </a:solidFill>
                   </a:tcPr>
                 </a:tc>
@@ -3760,7 +3760,7 @@
                       <a:pPr algn="ctr">
                         <a:defRPr sz="1100">
                           <a:solidFill>
-                            <a:srgbClr val="E2E8F0"/>
+                            <a:srgbClr val="1E293B"/>
                           </a:solidFill>
                         </a:defRPr>
                       </a:pPr>
@@ -3771,7 +3771,7 @@
                   </a:txBody>
                   <a:tcPr>
                     <a:solidFill>
-                      <a:srgbClr val="0B0F19"/>
+                      <a:srgbClr val="FCFAF2"/>
                     </a:solidFill>
                   </a:tcPr>
                 </a:tc>
@@ -3783,7 +3783,7 @@
                       <a:pPr algn="ctr">
                         <a:defRPr sz="1100">
                           <a:solidFill>
-                            <a:srgbClr val="E2E8F0"/>
+                            <a:srgbClr val="1E293B"/>
                           </a:solidFill>
                         </a:defRPr>
                       </a:pPr>
@@ -3794,7 +3794,7 @@
                   </a:txBody>
                   <a:tcPr>
                     <a:solidFill>
-                      <a:srgbClr val="0B0F19"/>
+                      <a:srgbClr val="FCFAF2"/>
                     </a:solidFill>
                   </a:tcPr>
                 </a:tc>
@@ -3806,7 +3806,7 @@
                       <a:pPr algn="ctr">
                         <a:defRPr sz="1100">
                           <a:solidFill>
-                            <a:srgbClr val="E2E8F0"/>
+                            <a:srgbClr val="1E293B"/>
                           </a:solidFill>
                         </a:defRPr>
                       </a:pPr>
@@ -3817,7 +3817,7 @@
                   </a:txBody>
                   <a:tcPr>
                     <a:solidFill>
-                      <a:srgbClr val="0B0F19"/>
+                      <a:srgbClr val="FCFAF2"/>
                     </a:solidFill>
                   </a:tcPr>
                 </a:tc>
@@ -3831,7 +3831,7 @@
                       <a:pPr algn="ctr">
                         <a:defRPr sz="1100">
                           <a:solidFill>
-                            <a:srgbClr val="E2E8F0"/>
+                            <a:srgbClr val="1E293B"/>
                           </a:solidFill>
                         </a:defRPr>
                       </a:pPr>
@@ -3842,7 +3842,7 @@
                   </a:txBody>
                   <a:tcPr>
                     <a:solidFill>
-                      <a:srgbClr val="0B0F19"/>
+                      <a:srgbClr val="F5F0E1"/>
                     </a:solidFill>
                   </a:tcPr>
                 </a:tc>
@@ -3854,7 +3854,7 @@
                       <a:pPr algn="ctr">
                         <a:defRPr sz="1100">
                           <a:solidFill>
-                            <a:srgbClr val="E2E8F0"/>
+                            <a:srgbClr val="1E293B"/>
                           </a:solidFill>
                         </a:defRPr>
                       </a:pPr>
@@ -3865,7 +3865,7 @@
                   </a:txBody>
                   <a:tcPr>
                     <a:solidFill>
-                      <a:srgbClr val="0B0F19"/>
+                      <a:srgbClr val="F5F0E1"/>
                     </a:solidFill>
                   </a:tcPr>
                 </a:tc>
@@ -3877,7 +3877,7 @@
                       <a:pPr algn="ctr">
                         <a:defRPr sz="1100">
                           <a:solidFill>
-                            <a:srgbClr val="E2E8F0"/>
+                            <a:srgbClr val="1E293B"/>
                           </a:solidFill>
                         </a:defRPr>
                       </a:pPr>
@@ -3888,7 +3888,7 @@
                   </a:txBody>
                   <a:tcPr>
                     <a:solidFill>
-                      <a:srgbClr val="0B0F19"/>
+                      <a:srgbClr val="F5F0E1"/>
                     </a:solidFill>
                   </a:tcPr>
                 </a:tc>
@@ -3900,7 +3900,7 @@
                       <a:pPr algn="ctr">
                         <a:defRPr sz="1100">
                           <a:solidFill>
-                            <a:srgbClr val="E2E8F0"/>
+                            <a:srgbClr val="1E293B"/>
                           </a:solidFill>
                         </a:defRPr>
                       </a:pPr>
@@ -3911,7 +3911,7 @@
                   </a:txBody>
                   <a:tcPr>
                     <a:solidFill>
-                      <a:srgbClr val="0B0F19"/>
+                      <a:srgbClr val="F5F0E1"/>
                     </a:solidFill>
                   </a:tcPr>
                 </a:tc>
@@ -3925,7 +3925,7 @@
                       <a:pPr algn="ctr">
                         <a:defRPr sz="1100">
                           <a:solidFill>
-                            <a:srgbClr val="E2E8F0"/>
+                            <a:srgbClr val="1E293B"/>
                           </a:solidFill>
                         </a:defRPr>
                       </a:pPr>
@@ -3936,7 +3936,7 @@
                   </a:txBody>
                   <a:tcPr>
                     <a:solidFill>
-                      <a:srgbClr val="0B0F19"/>
+                      <a:srgbClr val="FCFAF2"/>
                     </a:solidFill>
                   </a:tcPr>
                 </a:tc>
@@ -3948,7 +3948,7 @@
                       <a:pPr algn="ctr">
                         <a:defRPr sz="1100">
                           <a:solidFill>
-                            <a:srgbClr val="E2E8F0"/>
+                            <a:srgbClr val="1E293B"/>
                           </a:solidFill>
                         </a:defRPr>
                       </a:pPr>
@@ -3959,7 +3959,7 @@
                   </a:txBody>
                   <a:tcPr>
                     <a:solidFill>
-                      <a:srgbClr val="0B0F19"/>
+                      <a:srgbClr val="FCFAF2"/>
                     </a:solidFill>
                   </a:tcPr>
                 </a:tc>
@@ -3971,7 +3971,7 @@
                       <a:pPr algn="ctr">
                         <a:defRPr sz="1100">
                           <a:solidFill>
-                            <a:srgbClr val="E2E8F0"/>
+                            <a:srgbClr val="1E293B"/>
                           </a:solidFill>
                         </a:defRPr>
                       </a:pPr>
@@ -3982,7 +3982,7 @@
                   </a:txBody>
                   <a:tcPr>
                     <a:solidFill>
-                      <a:srgbClr val="0B0F19"/>
+                      <a:srgbClr val="FCFAF2"/>
                     </a:solidFill>
                   </a:tcPr>
                 </a:tc>
@@ -3994,7 +3994,7 @@
                       <a:pPr algn="ctr">
                         <a:defRPr sz="1100">
                           <a:solidFill>
-                            <a:srgbClr val="E2E8F0"/>
+                            <a:srgbClr val="1E293B"/>
                           </a:solidFill>
                         </a:defRPr>
                       </a:pPr>
@@ -4005,7 +4005,7 @@
                   </a:txBody>
                   <a:tcPr>
                     <a:solidFill>
-                      <a:srgbClr val="0B0F19"/>
+                      <a:srgbClr val="FCFAF2"/>
                     </a:solidFill>
                   </a:tcPr>
                 </a:tc>
@@ -4019,7 +4019,7 @@
                       <a:pPr algn="ctr">
                         <a:defRPr sz="1100">
                           <a:solidFill>
-                            <a:srgbClr val="E2E8F0"/>
+                            <a:srgbClr val="1E293B"/>
                           </a:solidFill>
                         </a:defRPr>
                       </a:pPr>
@@ -4030,7 +4030,7 @@
                   </a:txBody>
                   <a:tcPr>
                     <a:solidFill>
-                      <a:srgbClr val="0B0F19"/>
+                      <a:srgbClr val="F5F0E1"/>
                     </a:solidFill>
                   </a:tcPr>
                 </a:tc>
@@ -4042,7 +4042,7 @@
                       <a:pPr algn="ctr">
                         <a:defRPr sz="1100">
                           <a:solidFill>
-                            <a:srgbClr val="E2E8F0"/>
+                            <a:srgbClr val="1E293B"/>
                           </a:solidFill>
                         </a:defRPr>
                       </a:pPr>
@@ -4053,7 +4053,7 @@
                   </a:txBody>
                   <a:tcPr>
                     <a:solidFill>
-                      <a:srgbClr val="0B0F19"/>
+                      <a:srgbClr val="F5F0E1"/>
                     </a:solidFill>
                   </a:tcPr>
                 </a:tc>
@@ -4065,7 +4065,7 @@
                       <a:pPr algn="ctr">
                         <a:defRPr sz="1100">
                           <a:solidFill>
-                            <a:srgbClr val="E2E8F0"/>
+                            <a:srgbClr val="1E293B"/>
                           </a:solidFill>
                         </a:defRPr>
                       </a:pPr>
@@ -4076,7 +4076,7 @@
                   </a:txBody>
                   <a:tcPr>
                     <a:solidFill>
-                      <a:srgbClr val="0B0F19"/>
+                      <a:srgbClr val="F5F0E1"/>
                     </a:solidFill>
                   </a:tcPr>
                 </a:tc>
@@ -4088,7 +4088,7 @@
                       <a:pPr algn="ctr">
                         <a:defRPr sz="1100">
                           <a:solidFill>
-                            <a:srgbClr val="E2E8F0"/>
+                            <a:srgbClr val="1E293B"/>
                           </a:solidFill>
                         </a:defRPr>
                       </a:pPr>
@@ -4099,7 +4099,7 @@
                   </a:txBody>
                   <a:tcPr>
                     <a:solidFill>
-                      <a:srgbClr val="0B0F19"/>
+                      <a:srgbClr val="F5F0E1"/>
                     </a:solidFill>
                   </a:tcPr>
                 </a:tc>
@@ -4113,7 +4113,7 @@
                       <a:pPr algn="ctr">
                         <a:defRPr sz="1100">
                           <a:solidFill>
-                            <a:srgbClr val="E2E8F0"/>
+                            <a:srgbClr val="1E293B"/>
                           </a:solidFill>
                         </a:defRPr>
                       </a:pPr>
@@ -4124,7 +4124,7 @@
                   </a:txBody>
                   <a:tcPr>
                     <a:solidFill>
-                      <a:srgbClr val="0B0F19"/>
+                      <a:srgbClr val="FCFAF2"/>
                     </a:solidFill>
                   </a:tcPr>
                 </a:tc>
@@ -4136,7 +4136,7 @@
                       <a:pPr algn="ctr">
                         <a:defRPr sz="1100">
                           <a:solidFill>
-                            <a:srgbClr val="E2E8F0"/>
+                            <a:srgbClr val="1E293B"/>
                           </a:solidFill>
                         </a:defRPr>
                       </a:pPr>
@@ -4147,7 +4147,7 @@
                   </a:txBody>
                   <a:tcPr>
                     <a:solidFill>
-                      <a:srgbClr val="0B0F19"/>
+                      <a:srgbClr val="FCFAF2"/>
                     </a:solidFill>
                   </a:tcPr>
                 </a:tc>
@@ -4159,7 +4159,7 @@
                       <a:pPr algn="ctr">
                         <a:defRPr sz="1100">
                           <a:solidFill>
-                            <a:srgbClr val="E2E8F0"/>
+                            <a:srgbClr val="1E293B"/>
                           </a:solidFill>
                         </a:defRPr>
                       </a:pPr>
@@ -4170,7 +4170,7 @@
                   </a:txBody>
                   <a:tcPr>
                     <a:solidFill>
-                      <a:srgbClr val="0B0F19"/>
+                      <a:srgbClr val="FCFAF2"/>
                     </a:solidFill>
                   </a:tcPr>
                 </a:tc>
@@ -4182,7 +4182,7 @@
                       <a:pPr algn="ctr">
                         <a:defRPr sz="1100">
                           <a:solidFill>
-                            <a:srgbClr val="E2E8F0"/>
+                            <a:srgbClr val="1E293B"/>
                           </a:solidFill>
                         </a:defRPr>
                       </a:pPr>
@@ -4193,7 +4193,7 @@
                   </a:txBody>
                   <a:tcPr>
                     <a:solidFill>
-                      <a:srgbClr val="0B0F19"/>
+                      <a:srgbClr val="FCFAF2"/>
                     </a:solidFill>
                   </a:tcPr>
                 </a:tc>
@@ -4235,7 +4235,7 @@
             <a:avLst/>
           </a:prstGeom>
           <a:solidFill>
-            <a:srgbClr val="0B0F19"/>
+            <a:srgbClr val="FCFAF2"/>
           </a:solidFill>
           <a:ln>
             <a:noFill/>
@@ -4288,7 +4288,7 @@
             <a:pPr>
               <a:defRPr sz="2800" b="1">
                 <a:solidFill>
-                  <a:srgbClr val="38BDF8"/>
+                  <a:srgbClr val="927005"/>
                 </a:solidFill>
                 <a:latin typeface="Arial"/>
               </a:defRPr>
@@ -4324,7 +4324,7 @@
             <a:pPr>
               <a:defRPr sz="1600" b="1">
                 <a:solidFill>
-                  <a:srgbClr val="34D399"/>
+                  <a:srgbClr val="927005"/>
                 </a:solidFill>
                 <a:latin typeface="Arial"/>
               </a:defRPr>
@@ -4335,7 +4335,7 @@
             <a:r>
               <a:rPr b="0">
                 <a:solidFill>
-                  <a:srgbClr val="E2E8F0"/>
+                  <a:srgbClr val="1E293B"/>
                 </a:solidFill>
               </a:rPr>
               <a:t>Replaces manual document search with automated auditing engines and gap alerts, preparing safety coordinators instantly for audits.</a:t>
@@ -4348,7 +4348,7 @@
               </a:spcBef>
               <a:defRPr sz="1600" b="1">
                 <a:solidFill>
-                  <a:srgbClr val="34D399"/>
+                  <a:srgbClr val="927005"/>
                 </a:solidFill>
                 <a:latin typeface="Arial"/>
               </a:defRPr>
@@ -4359,7 +4359,7 @@
             <a:r>
               <a:rPr b="0">
                 <a:solidFill>
-                  <a:srgbClr val="E2E8F0"/>
+                  <a:srgbClr val="1E293B"/>
                 </a:solidFill>
               </a:rPr>
               <a:t>Enables field mechanics to retrieve grounded calibration steps in seconds, minimizing shutdown lengths.</a:t>
@@ -4372,7 +4372,7 @@
               </a:spcBef>
               <a:defRPr sz="1600" b="1">
                 <a:solidFill>
-                  <a:srgbClr val="34D399"/>
+                  <a:srgbClr val="927005"/>
                 </a:solidFill>
                 <a:latin typeface="Arial"/>
               </a:defRPr>
@@ -4383,7 +4383,7 @@
             <a:r>
               <a:rPr b="0">
                 <a:solidFill>
-                  <a:srgbClr val="E2E8F0"/>
+                  <a:srgbClr val="1E293B"/>
                 </a:solidFill>
               </a:rPr>
               <a:t>Identifies cavitation and wear early through root-cause summaries and simulation, reducing incident risks.</a:t>
@@ -4396,7 +4396,7 @@
               </a:spcBef>
               <a:defRPr sz="1600" b="1">
                 <a:solidFill>
-                  <a:srgbClr val="34D399"/>
+                  <a:srgbClr val="927005"/>
                 </a:solidFill>
                 <a:latin typeface="Arial"/>
               </a:defRPr>
@@ -4407,7 +4407,7 @@
             <a:r>
               <a:rPr b="0">
                 <a:solidFill>
-                  <a:srgbClr val="E2E8F0"/>
+                  <a:srgbClr val="1E293B"/>
                 </a:solidFill>
               </a:rPr>
               <a:t>Captures veteran diagnostic insights within local SQLite knowledge graphs, ensuring seamless team handovers.</a:t>
@@ -4448,7 +4448,7 @@
             <a:avLst/>
           </a:prstGeom>
           <a:solidFill>
-            <a:srgbClr val="0B0F19"/>
+            <a:srgbClr val="FCFAF2"/>
           </a:solidFill>
           <a:ln>
             <a:noFill/>
@@ -4501,7 +4501,7 @@
             <a:pPr>
               <a:defRPr sz="2800" b="1">
                 <a:solidFill>
-                  <a:srgbClr val="38BDF8"/>
+                  <a:srgbClr val="927005"/>
                 </a:solidFill>
                 <a:latin typeface="Arial"/>
               </a:defRPr>
@@ -4537,7 +4537,7 @@
             <a:pPr>
               <a:defRPr sz="1500" b="1">
                 <a:solidFill>
-                  <a:srgbClr val="38BDF8"/>
+                  <a:srgbClr val="927005"/>
                 </a:solidFill>
                 <a:latin typeface="Arial"/>
               </a:defRPr>
@@ -4548,7 +4548,7 @@
             <a:r>
               <a:rPr b="0">
                 <a:solidFill>
-                  <a:srgbClr val="E2E8F0"/>
+                  <a:srgbClr val="1E293B"/>
                 </a:solidFill>
               </a:rPr>
               <a:t>The SQLite + TF-IDF fallback configuration ensures portable edge runs without cloud dependencies or high resource footprints.</a:t>
@@ -4561,7 +4561,7 @@
               </a:spcBef>
               <a:defRPr sz="1500" b="1">
                 <a:solidFill>
-                  <a:srgbClr val="38BDF8"/>
+                  <a:srgbClr val="927005"/>
                 </a:solidFill>
                 <a:latin typeface="Arial"/>
               </a:defRPr>
@@ -4572,7 +4572,7 @@
             <a:r>
               <a:rPr b="0">
                 <a:solidFill>
-                  <a:srgbClr val="E2E8F0"/>
+                  <a:srgbClr val="1E293B"/>
                 </a:solidFill>
               </a:rPr>
               <a:t>Allows single-command container deployments on cloud servers or local plant control units.</a:t>
@@ -4585,7 +4585,7 @@
               </a:spcBef>
               <a:defRPr sz="1500" b="1">
                 <a:solidFill>
-                  <a:srgbClr val="38BDF8"/>
+                  <a:srgbClr val="927005"/>
                 </a:solidFill>
                 <a:latin typeface="Arial"/>
               </a:defRPr>
@@ -4596,7 +4596,7 @@
             <a:r>
               <a:rPr b="0">
                 <a:solidFill>
-                  <a:srgbClr val="E2E8F0"/>
+                  <a:srgbClr val="1E293B"/>
                 </a:solidFill>
               </a:rPr>
               <a:t>The roadmap includes linking live vibration and flow telemetry directly to Digital Twins, automating simulations on sensor threshold alerts.</a:t>
@@ -4609,7 +4609,7 @@
               </a:spcBef>
               <a:defRPr sz="1500" b="1">
                 <a:solidFill>
-                  <a:srgbClr val="38BDF8"/>
+                  <a:srgbClr val="927005"/>
                 </a:solidFill>
                 <a:latin typeface="Arial"/>
               </a:defRPr>
@@ -4620,7 +4620,7 @@
             <a:r>
               <a:rPr b="0">
                 <a:solidFill>
-                  <a:srgbClr val="E2E8F0"/>
+                  <a:srgbClr val="1E293B"/>
                 </a:solidFill>
               </a:rPr>
               <a:t>Integrates computer vision models to read engineering drawings (P&amp;IDs), parsing piping and valves directly into knowledge graph nodes.</a:t>
@@ -4661,7 +4661,7 @@
             <a:avLst/>
           </a:prstGeom>
           <a:solidFill>
-            <a:srgbClr val="0B0F19"/>
+            <a:srgbClr val="FCFAF2"/>
           </a:solidFill>
           <a:ln>
             <a:noFill/>
@@ -4714,7 +4714,7 @@
             <a:pPr>
               <a:defRPr sz="2800" b="1">
                 <a:solidFill>
-                  <a:srgbClr val="38BDF8"/>
+                  <a:srgbClr val="927005"/>
                 </a:solidFill>
                 <a:latin typeface="Arial"/>
               </a:defRPr>
@@ -4758,7 +4758,7 @@
                       <a:pPr algn="ctr">
                         <a:defRPr b="1" sz="1400">
                           <a:solidFill>
-                            <a:srgbClr val="38BDF8"/>
+                            <a:srgbClr val="1E293B"/>
                           </a:solidFill>
                         </a:defRPr>
                       </a:pPr>
@@ -4769,7 +4769,7 @@
                   </a:txBody>
                   <a:tcPr>
                     <a:solidFill>
-                      <a:srgbClr val="0B0F19"/>
+                      <a:srgbClr val="E8DFC5"/>
                     </a:solidFill>
                   </a:tcPr>
                 </a:tc>
@@ -4781,7 +4781,7 @@
                       <a:pPr algn="ctr">
                         <a:defRPr b="1" sz="1400">
                           <a:solidFill>
-                            <a:srgbClr val="38BDF8"/>
+                            <a:srgbClr val="1E293B"/>
                           </a:solidFill>
                         </a:defRPr>
                       </a:pPr>
@@ -4792,7 +4792,7 @@
                   </a:txBody>
                   <a:tcPr>
                     <a:solidFill>
-                      <a:srgbClr val="0B0F19"/>
+                      <a:srgbClr val="E8DFC5"/>
                     </a:solidFill>
                   </a:tcPr>
                 </a:tc>
@@ -4804,7 +4804,7 @@
                       <a:pPr algn="ctr">
                         <a:defRPr b="1" sz="1400">
                           <a:solidFill>
-                            <a:srgbClr val="38BDF8"/>
+                            <a:srgbClr val="1E293B"/>
                           </a:solidFill>
                         </a:defRPr>
                       </a:pPr>
@@ -4815,7 +4815,7 @@
                   </a:txBody>
                   <a:tcPr>
                     <a:solidFill>
-                      <a:srgbClr val="0B0F19"/>
+                      <a:srgbClr val="E8DFC5"/>
                     </a:solidFill>
                   </a:tcPr>
                 </a:tc>
@@ -4827,7 +4827,7 @@
                       <a:pPr algn="ctr">
                         <a:defRPr b="1" sz="1400">
                           <a:solidFill>
-                            <a:srgbClr val="38BDF8"/>
+                            <a:srgbClr val="1E293B"/>
                           </a:solidFill>
                         </a:defRPr>
                       </a:pPr>
@@ -4838,7 +4838,7 @@
                   </a:txBody>
                   <a:tcPr>
                     <a:solidFill>
-                      <a:srgbClr val="0B0F19"/>
+                      <a:srgbClr val="E8DFC5"/>
                     </a:solidFill>
                   </a:tcPr>
                 </a:tc>
@@ -4852,7 +4852,7 @@
                       <a:pPr algn="ctr">
                         <a:defRPr sz="1200">
                           <a:solidFill>
-                            <a:srgbClr val="E2E8F0"/>
+                            <a:srgbClr val="1E293B"/>
                           </a:solidFill>
                         </a:defRPr>
                       </a:pPr>
@@ -4863,7 +4863,7 @@
                   </a:txBody>
                   <a:tcPr>
                     <a:solidFill>
-                      <a:srgbClr val="0B0F19"/>
+                      <a:srgbClr val="FCFAF2"/>
                     </a:solidFill>
                   </a:tcPr>
                 </a:tc>
@@ -4875,7 +4875,7 @@
                       <a:pPr algn="l">
                         <a:defRPr sz="1200">
                           <a:solidFill>
-                            <a:srgbClr val="E2E8F0"/>
+                            <a:srgbClr val="1E293B"/>
                           </a:solidFill>
                         </a:defRPr>
                       </a:pPr>
@@ -4886,7 +4886,7 @@
                   </a:txBody>
                   <a:tcPr>
                     <a:solidFill>
-                      <a:srgbClr val="0B0F19"/>
+                      <a:srgbClr val="FCFAF2"/>
                     </a:solidFill>
                   </a:tcPr>
                 </a:tc>
@@ -4898,7 +4898,7 @@
                       <a:pPr algn="l">
                         <a:defRPr sz="1200">
                           <a:solidFill>
-                            <a:srgbClr val="E2E8F0"/>
+                            <a:srgbClr val="1E293B"/>
                           </a:solidFill>
                         </a:defRPr>
                       </a:pPr>
@@ -4909,7 +4909,7 @@
                   </a:txBody>
                   <a:tcPr>
                     <a:solidFill>
-                      <a:srgbClr val="0B0F19"/>
+                      <a:srgbClr val="FCFAF2"/>
                     </a:solidFill>
                   </a:tcPr>
                 </a:tc>
@@ -4921,7 +4921,7 @@
                       <a:pPr algn="l">
                         <a:defRPr sz="1200">
                           <a:solidFill>
-                            <a:srgbClr val="E2E8F0"/>
+                            <a:srgbClr val="1E293B"/>
                           </a:solidFill>
                         </a:defRPr>
                       </a:pPr>
@@ -4932,7 +4932,7 @@
                   </a:txBody>
                   <a:tcPr>
                     <a:solidFill>
-                      <a:srgbClr val="0B0F19"/>
+                      <a:srgbClr val="FCFAF2"/>
                     </a:solidFill>
                   </a:tcPr>
                 </a:tc>
@@ -4946,18 +4946,18 @@
                       <a:pPr algn="ctr">
                         <a:defRPr sz="1200">
                           <a:solidFill>
-                            <a:srgbClr val="E2E8F0"/>
+                            <a:srgbClr val="1E293B"/>
                           </a:solidFill>
                         </a:defRPr>
                       </a:pPr>
                       <a:r>
-                        <a:t>System Connectivity</a:t>
+                        <a:t>System Connections</a:t>
                       </a:r>
                     </a:p>
                   </a:txBody>
                   <a:tcPr>
                     <a:solidFill>
-                      <a:srgbClr val="0B0F19"/>
+                      <a:srgbClr val="F5F0E1"/>
                     </a:solidFill>
                   </a:tcPr>
                 </a:tc>
@@ -4969,7 +4969,7 @@
                       <a:pPr algn="l">
                         <a:defRPr sz="1200">
                           <a:solidFill>
-                            <a:srgbClr val="E2E8F0"/>
+                            <a:srgbClr val="1E293B"/>
                           </a:solidFill>
                         </a:defRPr>
                       </a:pPr>
@@ -4980,7 +4980,7 @@
                   </a:txBody>
                   <a:tcPr>
                     <a:solidFill>
-                      <a:srgbClr val="0B0F19"/>
+                      <a:srgbClr val="F5F0E1"/>
                     </a:solidFill>
                   </a:tcPr>
                 </a:tc>
@@ -4992,7 +4992,7 @@
                       <a:pPr algn="l">
                         <a:defRPr sz="1200">
                           <a:solidFill>
-                            <a:srgbClr val="E2E8F0"/>
+                            <a:srgbClr val="1E293B"/>
                           </a:solidFill>
                         </a:defRPr>
                       </a:pPr>
@@ -5003,7 +5003,7 @@
                   </a:txBody>
                   <a:tcPr>
                     <a:solidFill>
-                      <a:srgbClr val="0B0F19"/>
+                      <a:srgbClr val="F5F0E1"/>
                     </a:solidFill>
                   </a:tcPr>
                 </a:tc>
@@ -5015,7 +5015,7 @@
                       <a:pPr algn="l">
                         <a:defRPr sz="1200">
                           <a:solidFill>
-                            <a:srgbClr val="E2E8F0"/>
+                            <a:srgbClr val="1E293B"/>
                           </a:solidFill>
                         </a:defRPr>
                       </a:pPr>
@@ -5026,7 +5026,7 @@
                   </a:txBody>
                   <a:tcPr>
                     <a:solidFill>
-                      <a:srgbClr val="0B0F19"/>
+                      <a:srgbClr val="F5F0E1"/>
                     </a:solidFill>
                   </a:tcPr>
                 </a:tc>
@@ -5040,18 +5040,18 @@
                       <a:pPr algn="ctr">
                         <a:defRPr sz="1200">
                           <a:solidFill>
-                            <a:srgbClr val="E2E8F0"/>
+                            <a:srgbClr val="1E293B"/>
                           </a:solidFill>
                         </a:defRPr>
                       </a:pPr>
                       <a:r>
-                        <a:t>Availability / Offline Mode</a:t>
+                        <a:t>Availability Mode</a:t>
                       </a:r>
                     </a:p>
                   </a:txBody>
                   <a:tcPr>
                     <a:solidFill>
-                      <a:srgbClr val="0B0F19"/>
+                      <a:srgbClr val="FCFAF2"/>
                     </a:solidFill>
                   </a:tcPr>
                 </a:tc>
@@ -5063,7 +5063,7 @@
                       <a:pPr algn="l">
                         <a:defRPr sz="1200">
                           <a:solidFill>
-                            <a:srgbClr val="E2E8F0"/>
+                            <a:srgbClr val="1E293B"/>
                           </a:solidFill>
                         </a:defRPr>
                       </a:pPr>
@@ -5074,7 +5074,7 @@
                   </a:txBody>
                   <a:tcPr>
                     <a:solidFill>
-                      <a:srgbClr val="0B0F19"/>
+                      <a:srgbClr val="FCFAF2"/>
                     </a:solidFill>
                   </a:tcPr>
                 </a:tc>
@@ -5086,7 +5086,7 @@
                       <a:pPr algn="l">
                         <a:defRPr sz="1200">
                           <a:solidFill>
-                            <a:srgbClr val="E2E8F0"/>
+                            <a:srgbClr val="1E293B"/>
                           </a:solidFill>
                         </a:defRPr>
                       </a:pPr>
@@ -5097,7 +5097,7 @@
                   </a:txBody>
                   <a:tcPr>
                     <a:solidFill>
-                      <a:srgbClr val="0B0F19"/>
+                      <a:srgbClr val="FCFAF2"/>
                     </a:solidFill>
                   </a:tcPr>
                 </a:tc>
@@ -5109,7 +5109,7 @@
                       <a:pPr algn="l">
                         <a:defRPr sz="1200">
                           <a:solidFill>
-                            <a:srgbClr val="E2E8F0"/>
+                            <a:srgbClr val="1E293B"/>
                           </a:solidFill>
                         </a:defRPr>
                       </a:pPr>
@@ -5120,7 +5120,7 @@
                   </a:txBody>
                   <a:tcPr>
                     <a:solidFill>
-                      <a:srgbClr val="0B0F19"/>
+                      <a:srgbClr val="FCFAF2"/>
                     </a:solidFill>
                   </a:tcPr>
                 </a:tc>
@@ -5162,7 +5162,7 @@
             <a:avLst/>
           </a:prstGeom>
           <a:solidFill>
-            <a:srgbClr val="0B0F19"/>
+            <a:srgbClr val="FCFAF2"/>
           </a:solidFill>
           <a:ln>
             <a:noFill/>
@@ -5215,7 +5215,7 @@
             <a:pPr>
               <a:defRPr sz="2800" b="1">
                 <a:solidFill>
-                  <a:srgbClr val="38BDF8"/>
+                  <a:srgbClr val="927005"/>
                 </a:solidFill>
                 <a:latin typeface="Arial"/>
               </a:defRPr>
@@ -5251,7 +5251,7 @@
             <a:pPr>
               <a:defRPr sz="1500" b="1">
                 <a:solidFill>
-                  <a:srgbClr val="34D399"/>
+                  <a:srgbClr val="927005"/>
                 </a:solidFill>
                 <a:latin typeface="Arial"/>
               </a:defRPr>
@@ -5262,7 +5262,7 @@
             <a:r>
               <a:rPr b="0">
                 <a:solidFill>
-                  <a:srgbClr val="E2E8F0"/>
+                  <a:srgbClr val="1E293B"/>
                 </a:solidFill>
               </a:rPr>
               <a:t>Combines semantic text search (RAG) with SQLite relational graph layers to offer comprehensive operational insights.</a:t>
@@ -5275,7 +5275,7 @@
               </a:spcBef>
               <a:defRPr sz="1500" b="1">
                 <a:solidFill>
-                  <a:srgbClr val="34D399"/>
+                  <a:srgbClr val="927005"/>
                 </a:solidFill>
                 <a:latin typeface="Arial"/>
               </a:defRPr>
@@ -5286,7 +5286,7 @@
             <a:r>
               <a:rPr b="0">
                 <a:solidFill>
-                  <a:srgbClr val="E2E8F0"/>
+                  <a:srgbClr val="1E293B"/>
                 </a:solidFill>
               </a:rPr>
               <a:t>Addresses high-cost industrial downtime ($45K/hr) and automates complex regulatory compliance workflows.</a:t>
@@ -5299,7 +5299,7 @@
               </a:spcBef>
               <a:defRPr sz="1500" b="1">
                 <a:solidFill>
-                  <a:srgbClr val="34D399"/>
+                  <a:srgbClr val="927005"/>
                 </a:solidFill>
                 <a:latin typeface="Arial"/>
               </a:defRPr>
@@ -5310,7 +5310,7 @@
             <a:r>
               <a:rPr b="0">
                 <a:solidFill>
-                  <a:srgbClr val="E2E8F0"/>
+                  <a:srgbClr val="1E293B"/>
                 </a:solidFill>
               </a:rPr>
               <a:t>Delivers robust offline fallbacks, key rotations, and custom parsers packed into a lightweight edge profile.</a:t>
@@ -5323,7 +5323,7 @@
               </a:spcBef>
               <a:defRPr sz="1500" b="1">
                 <a:solidFill>
-                  <a:srgbClr val="34D399"/>
+                  <a:srgbClr val="927005"/>
                 </a:solidFill>
                 <a:latin typeface="Arial"/>
               </a:defRPr>
@@ -5334,7 +5334,7 @@
             <a:r>
               <a:rPr b="0">
                 <a:solidFill>
-                  <a:srgbClr val="E2E8F0"/>
+                  <a:srgbClr val="1E293B"/>
                 </a:solidFill>
               </a:rPr>
               <a:t>Decoupled container builds (FastAPI, React, SQLite) ensure scalable edge deployment out-of-the-box.</a:t>
@@ -5347,7 +5347,7 @@
               </a:spcBef>
               <a:defRPr sz="1500" b="1">
                 <a:solidFill>
-                  <a:srgbClr val="34D399"/>
+                  <a:srgbClr val="927005"/>
                 </a:solidFill>
                 <a:latin typeface="Arial"/>
               </a:defRPr>
@@ -5358,7 +5358,7 @@
             <a:r>
               <a:rPr b="0">
                 <a:solidFill>
-                  <a:srgbClr val="E2E8F0"/>
+                  <a:srgbClr val="1E293B"/>
                 </a:solidFill>
               </a:rPr>
               <a:t>Features an interactive physics graph and citation slides, putting details at operators' fingertips.</a:t>
@@ -5399,7 +5399,7 @@
             <a:avLst/>
           </a:prstGeom>
           <a:solidFill>
-            <a:srgbClr val="0B0F19"/>
+            <a:srgbClr val="FCFAF2"/>
           </a:solidFill>
           <a:ln>
             <a:noFill/>
@@ -5452,7 +5452,7 @@
             <a:pPr algn="ctr">
               <a:defRPr sz="5600" b="1">
                 <a:solidFill>
-                  <a:srgbClr val="38BDF8"/>
+                  <a:srgbClr val="927005"/>
                 </a:solidFill>
                 <a:latin typeface="Arial"/>
               </a:defRPr>
@@ -5468,7 +5468,7 @@
               </a:spcBef>
               <a:defRPr sz="2000" b="1">
                 <a:solidFill>
-                  <a:srgbClr val="34D399"/>
+                  <a:srgbClr val="1E293B"/>
                 </a:solidFill>
                 <a:latin typeface="Arial"/>
               </a:defRPr>
@@ -5484,7 +5484,7 @@
               </a:spcBef>
               <a:defRPr sz="1400">
                 <a:solidFill>
-                  <a:srgbClr val="94A3B8"/>
+                  <a:srgbClr val="64748B"/>
                 </a:solidFill>
                 <a:latin typeface="Arial"/>
               </a:defRPr>
@@ -5528,7 +5528,7 @@
             <a:avLst/>
           </a:prstGeom>
           <a:solidFill>
-            <a:srgbClr val="0B0F19"/>
+            <a:srgbClr val="FCFAF2"/>
           </a:solidFill>
           <a:ln>
             <a:noFill/>
@@ -5581,7 +5581,7 @@
             <a:pPr>
               <a:defRPr sz="2800" b="1">
                 <a:solidFill>
-                  <a:srgbClr val="38BDF8"/>
+                  <a:srgbClr val="927005"/>
                 </a:solidFill>
                 <a:latin typeface="Arial"/>
               </a:defRPr>
@@ -5617,7 +5617,7 @@
             <a:pPr>
               <a:defRPr sz="1600" b="1">
                 <a:solidFill>
-                  <a:srgbClr val="34D399"/>
+                  <a:srgbClr val="927005"/>
                 </a:solidFill>
                 <a:latin typeface="Arial"/>
               </a:defRPr>
@@ -5628,10 +5628,10 @@
             <a:r>
               <a:rPr b="0">
                 <a:solidFill>
-                  <a:srgbClr val="E2E8F0"/>
+                  <a:srgbClr val="1E293B"/>
                 </a:solidFill>
               </a:rPr>
-              <a:t>Procedures, checklists, audit findings, and manuals are scattered in separate folders and file formats.</a:t>
+              <a:t>Procedures, checklists, audit reports, and manuals are scattered in separate folders and file formats.</a:t>
             </a:r>
           </a:p>
           <a:p>
@@ -5641,7 +5641,7 @@
               </a:spcBef>
               <a:defRPr sz="1600" b="1">
                 <a:solidFill>
-                  <a:srgbClr val="34D399"/>
+                  <a:srgbClr val="927005"/>
                 </a:solidFill>
                 <a:latin typeface="Arial"/>
               </a:defRPr>
@@ -5652,7 +5652,7 @@
             <a:r>
               <a:rPr b="0">
                 <a:solidFill>
-                  <a:srgbClr val="E2E8F0"/>
+                  <a:srgbClr val="1E293B"/>
                 </a:solidFill>
               </a:rPr>
               <a:t>Delays in technical retrieval lengthen troubleshooting times, costing up to $45,000 per hour of shutdown.</a:t>
@@ -5665,7 +5665,7 @@
               </a:spcBef>
               <a:defRPr sz="1600" b="1">
                 <a:solidFill>
-                  <a:srgbClr val="34D399"/>
+                  <a:srgbClr val="927005"/>
                 </a:solidFill>
                 <a:latin typeface="Arial"/>
               </a:defRPr>
@@ -5676,7 +5676,7 @@
             <a:r>
               <a:rPr b="0">
                 <a:solidFill>
-                  <a:srgbClr val="E2E8F0"/>
+                  <a:srgbClr val="1E293B"/>
                 </a:solidFill>
               </a:rPr>
               <a:t>Manual auditing fails to detect expired certifications or skipped maintenance tasks, creating regulatory and safety risks.</a:t>
@@ -5689,7 +5689,7 @@
               </a:spcBef>
               <a:defRPr sz="1600" b="1">
                 <a:solidFill>
-                  <a:srgbClr val="34D399"/>
+                  <a:srgbClr val="927005"/>
                 </a:solidFill>
                 <a:latin typeface="Arial"/>
               </a:defRPr>
@@ -5700,7 +5700,7 @@
             <a:r>
               <a:rPr b="0">
                 <a:solidFill>
-                  <a:srgbClr val="E2E8F0"/>
+                  <a:srgbClr val="1E293B"/>
                 </a:solidFill>
               </a:rPr>
               <a:t>Expert tribal knowledge escapes as senior operators retire, leaving no digitized diagnostic reference.</a:t>
@@ -5733,7 +5733,7 @@
             <a:pPr algn="ctr">
               <a:defRPr sz="5600" b="1">
                 <a:solidFill>
-                  <a:srgbClr val="DC2626"/>
+                  <a:srgbClr val="B91C1C"/>
                 </a:solidFill>
               </a:defRPr>
             </a:pPr>
@@ -5745,7 +5745,7 @@
             <a:pPr algn="ctr">
               <a:defRPr sz="1600" b="1">
                 <a:solidFill>
-                  <a:srgbClr val="E2E8F0"/>
+                  <a:srgbClr val="1E293B"/>
                 </a:solidFill>
               </a:defRPr>
             </a:pPr>
@@ -5760,7 +5760,7 @@
               </a:spcBef>
               <a:defRPr sz="1400">
                 <a:solidFill>
-                  <a:srgbClr val="94A3B8"/>
+                  <a:srgbClr val="64748B"/>
                 </a:solidFill>
               </a:defRPr>
             </a:pPr>
@@ -5803,7 +5803,7 @@
             <a:avLst/>
           </a:prstGeom>
           <a:solidFill>
-            <a:srgbClr val="0B0F19"/>
+            <a:srgbClr val="FCFAF2"/>
           </a:solidFill>
           <a:ln>
             <a:noFill/>
@@ -5856,7 +5856,7 @@
             <a:pPr>
               <a:defRPr sz="2800" b="1">
                 <a:solidFill>
-                  <a:srgbClr val="38BDF8"/>
+                  <a:srgbClr val="927005"/>
                 </a:solidFill>
                 <a:latin typeface="Arial"/>
               </a:defRPr>
@@ -5892,7 +5892,7 @@
             <a:pPr>
               <a:defRPr sz="1600" b="1">
                 <a:solidFill>
-                  <a:srgbClr val="34D399"/>
+                  <a:srgbClr val="927005"/>
                 </a:solidFill>
                 <a:latin typeface="Arial"/>
               </a:defRPr>
@@ -5903,7 +5903,7 @@
             <a:r>
               <a:rPr b="0">
                 <a:solidFill>
-                  <a:srgbClr val="E2E8F0"/>
+                  <a:srgbClr val="1E293B"/>
                 </a:solidFill>
               </a:rPr>
               <a:t>Power complexes, chemical plants, and oil refineries operate under extreme hazard conditions where manual diagnostics trigger delayed reaction times.</a:t>
@@ -5916,7 +5916,7 @@
               </a:spcBef>
               <a:defRPr sz="1600" b="1">
                 <a:solidFill>
-                  <a:srgbClr val="34D399"/>
+                  <a:srgbClr val="927005"/>
                 </a:solidFill>
                 <a:latin typeface="Arial"/>
               </a:defRPr>
@@ -5927,7 +5927,7 @@
             <a:r>
               <a:rPr b="0">
                 <a:solidFill>
-                  <a:srgbClr val="E2E8F0"/>
+                  <a:srgbClr val="1E293B"/>
                 </a:solidFill>
               </a:rPr>
               <a:t>Annual compliance audits require manual evaluation of safety standards. Failing an audit incurs severe penalties and risks operational freezes.</a:t>
@@ -5940,7 +5940,7 @@
               </a:spcBef>
               <a:defRPr sz="1600" b="1">
                 <a:solidFill>
-                  <a:srgbClr val="34D399"/>
+                  <a:srgbClr val="927005"/>
                 </a:solidFill>
                 <a:latin typeface="Arial"/>
               </a:defRPr>
@@ -5951,7 +5951,7 @@
             <a:r>
               <a:rPr b="0">
                 <a:solidFill>
-                  <a:srgbClr val="E2E8F0"/>
+                  <a:srgbClr val="1E293B"/>
                 </a:solidFill>
               </a:rPr>
               <a:t>Without contextual search, mechanics perform redundant trial-and-error troubleshooting on heavy machinery.</a:t>
@@ -5984,7 +5984,7 @@
             <a:pPr>
               <a:defRPr sz="1600" b="1">
                 <a:solidFill>
-                  <a:srgbClr val="38BDF8"/>
+                  <a:srgbClr val="927005"/>
                 </a:solidFill>
               </a:defRPr>
             </a:pPr>
@@ -5999,7 +5999,7 @@
               </a:spcBef>
               <a:defRPr sz="1500">
                 <a:solidFill>
-                  <a:srgbClr val="E2E8F0"/>
+                  <a:srgbClr val="1E293B"/>
                 </a:solidFill>
               </a:defRPr>
             </a:pPr>
@@ -6014,7 +6014,7 @@
               </a:spcBef>
               <a:defRPr sz="1500">
                 <a:solidFill>
-                  <a:srgbClr val="E2E8F0"/>
+                  <a:srgbClr val="1E293B"/>
                 </a:solidFill>
               </a:defRPr>
             </a:pPr>
@@ -6029,7 +6029,7 @@
               </a:spcBef>
               <a:defRPr sz="1500">
                 <a:solidFill>
-                  <a:srgbClr val="E2E8F0"/>
+                  <a:srgbClr val="1E293B"/>
                 </a:solidFill>
               </a:defRPr>
             </a:pPr>
@@ -6044,7 +6044,7 @@
               </a:spcBef>
               <a:defRPr sz="1500">
                 <a:solidFill>
-                  <a:srgbClr val="E2E8F0"/>
+                  <a:srgbClr val="1E293B"/>
                 </a:solidFill>
               </a:defRPr>
             </a:pPr>
@@ -6087,7 +6087,7 @@
             <a:avLst/>
           </a:prstGeom>
           <a:solidFill>
-            <a:srgbClr val="0B0F19"/>
+            <a:srgbClr val="FCFAF2"/>
           </a:solidFill>
           <a:ln>
             <a:noFill/>
@@ -6140,7 +6140,7 @@
             <a:pPr>
               <a:defRPr sz="2800" b="1">
                 <a:solidFill>
-                  <a:srgbClr val="38BDF8"/>
+                  <a:srgbClr val="927005"/>
                 </a:solidFill>
                 <a:latin typeface="Arial"/>
               </a:defRPr>
@@ -6176,7 +6176,7 @@
             <a:pPr>
               <a:defRPr sz="1600" b="1">
                 <a:solidFill>
-                  <a:srgbClr val="38BDF8"/>
+                  <a:srgbClr val="927005"/>
                 </a:solidFill>
                 <a:latin typeface="Arial"/>
               </a:defRPr>
@@ -6187,7 +6187,7 @@
             <a:r>
               <a:rPr b="0">
                 <a:solidFill>
-                  <a:srgbClr val="E2E8F0"/>
+                  <a:srgbClr val="1E293B"/>
                 </a:solidFill>
               </a:rPr>
               <a:t>Renders instant Plant Health scores, compliance gaps, downtime risks, and incident lists for high-level management oversight.</a:t>
@@ -6200,7 +6200,7 @@
               </a:spcBef>
               <a:defRPr sz="1600" b="1">
                 <a:solidFill>
-                  <a:srgbClr val="38BDF8"/>
+                  <a:srgbClr val="927005"/>
                 </a:solidFill>
                 <a:latin typeface="Arial"/>
               </a:defRPr>
@@ -6211,7 +6211,7 @@
             <a:r>
               <a:rPr b="0">
                 <a:solidFill>
-                  <a:srgbClr val="E2E8F0"/>
+                  <a:srgbClr val="1E293B"/>
                 </a:solidFill>
               </a:rPr>
               <a:t>Retrieves safety regulations, equipment procedures, and records, displaying the exact source filename and page numbers to prevent AI hallucination.</a:t>
@@ -6224,7 +6224,7 @@
               </a:spcBef>
               <a:defRPr sz="1600" b="1">
                 <a:solidFill>
-                  <a:srgbClr val="38BDF8"/>
+                  <a:srgbClr val="927005"/>
                 </a:solidFill>
                 <a:latin typeface="Arial"/>
               </a:defRPr>
@@ -6235,7 +6235,7 @@
             <a:r>
               <a:rPr b="0">
                 <a:solidFill>
-                  <a:srgbClr val="E2E8F0"/>
+                  <a:srgbClr val="1E293B"/>
                 </a:solidFill>
               </a:rPr>
               <a:t>Visualizes connections across assets, maintenance logs, and audit codes on a live interactive physics-directed graph.</a:t>
@@ -6248,7 +6248,7 @@
               </a:spcBef>
               <a:defRPr sz="1600" b="1">
                 <a:solidFill>
-                  <a:srgbClr val="38BDF8"/>
+                  <a:srgbClr val="927005"/>
                 </a:solidFill>
                 <a:latin typeface="Arial"/>
               </a:defRPr>
@@ -6259,7 +6259,7 @@
             <a:r>
               <a:rPr b="0">
                 <a:solidFill>
-                  <a:srgbClr val="E2E8F0"/>
+                  <a:srgbClr val="1E293B"/>
                 </a:solidFill>
               </a:rPr>
               <a:t>Extracts recurring breakdown root causes, flags regulatory gaps, and recalibrates safety compliance scores via corrective task checklists.</a:t>
@@ -6300,7 +6300,7 @@
             <a:avLst/>
           </a:prstGeom>
           <a:solidFill>
-            <a:srgbClr val="0B0F19"/>
+            <a:srgbClr val="FCFAF2"/>
           </a:solidFill>
           <a:ln>
             <a:noFill/>
@@ -6353,7 +6353,7 @@
             <a:pPr>
               <a:defRPr sz="2800" b="1">
                 <a:solidFill>
-                  <a:srgbClr val="38BDF8"/>
+                  <a:srgbClr val="927005"/>
                 </a:solidFill>
                 <a:latin typeface="Arial"/>
               </a:defRPr>
@@ -6389,7 +6389,7 @@
             <a:pPr>
               <a:defRPr sz="1400" b="1">
                 <a:solidFill>
-                  <a:srgbClr val="34D399"/>
+                  <a:srgbClr val="927005"/>
                 </a:solidFill>
               </a:defRPr>
             </a:pPr>
@@ -6399,7 +6399,7 @@
             <a:r>
               <a:rPr b="0">
                 <a:solidFill>
-                  <a:srgbClr val="E2E8F0"/>
+                  <a:srgbClr val="1E293B"/>
                 </a:solidFill>
               </a:rPr>
               <a:t>Ingests PDFs, CSVs, and scanned files, running simulated OCR pipelines to compile clean text layers.</a:t>
@@ -6412,7 +6412,7 @@
               </a:spcBef>
               <a:defRPr sz="1400" b="1">
                 <a:solidFill>
-                  <a:srgbClr val="34D399"/>
+                  <a:srgbClr val="927005"/>
                 </a:solidFill>
               </a:defRPr>
             </a:pPr>
@@ -6422,7 +6422,7 @@
             <a:r>
               <a:rPr b="0">
                 <a:solidFill>
-                  <a:srgbClr val="E2E8F0"/>
+                  <a:srgbClr val="1E293B"/>
                 </a:solidFill>
               </a:rPr>
               <a:t>Scans text chunks to extract equipment codes, failure modes, regulations, and verb-level relationships.</a:t>
@@ -6435,7 +6435,7 @@
               </a:spcBef>
               <a:defRPr sz="1400" b="1">
                 <a:solidFill>
-                  <a:srgbClr val="34D399"/>
+                  <a:srgbClr val="927005"/>
                 </a:solidFill>
               </a:defRPr>
             </a:pPr>
@@ -6445,7 +6445,7 @@
             <a:r>
               <a:rPr b="0">
                 <a:solidFill>
-                  <a:srgbClr val="E2E8F0"/>
+                  <a:srgbClr val="1E293B"/>
                 </a:solidFill>
               </a:rPr>
               <a:t>Stores assets, incidents, maintenance events, rules, extracted nodes, and edges inside local relational tables.</a:t>
@@ -6458,7 +6458,7 @@
               </a:spcBef>
               <a:defRPr sz="1400" b="1">
                 <a:solidFill>
-                  <a:srgbClr val="34D399"/>
+                  <a:srgbClr val="927005"/>
                 </a:solidFill>
               </a:defRPr>
             </a:pPr>
@@ -6468,7 +6468,7 @@
             <a:r>
               <a:rPr b="0">
                 <a:solidFill>
-                  <a:srgbClr val="E2E8F0"/>
+                  <a:srgbClr val="1E293B"/>
                 </a:solidFill>
               </a:rPr>
               <a:t>Implements local word overlap RAG queries, eliminating remote cloud vectors and API dependency.</a:t>
@@ -6533,7 +6533,7 @@
             <a:avLst/>
           </a:prstGeom>
           <a:solidFill>
-            <a:srgbClr val="0B0F19"/>
+            <a:srgbClr val="FCFAF2"/>
           </a:solidFill>
           <a:ln>
             <a:noFill/>
@@ -6586,7 +6586,7 @@
             <a:pPr>
               <a:defRPr sz="2800" b="1">
                 <a:solidFill>
-                  <a:srgbClr val="38BDF8"/>
+                  <a:srgbClr val="927005"/>
                 </a:solidFill>
                 <a:latin typeface="Arial"/>
               </a:defRPr>
@@ -6622,7 +6622,7 @@
             <a:pPr>
               <a:defRPr sz="1400" b="1">
                 <a:solidFill>
-                  <a:srgbClr val="34D399"/>
+                  <a:srgbClr val="927005"/>
                 </a:solidFill>
               </a:defRPr>
             </a:pPr>
@@ -6632,7 +6632,7 @@
             <a:r>
               <a:rPr b="0">
                 <a:solidFill>
-                  <a:srgbClr val="E2E8F0"/>
+                  <a:srgbClr val="1E293B"/>
                 </a:solidFill>
               </a:rPr>
               <a:t>Assets are linked to procedures (SOPs), safety findings, and maintenance events. This builds logic paths beyond search.</a:t>
@@ -6645,7 +6645,7 @@
               </a:spcBef>
               <a:defRPr sz="1400" b="1">
                 <a:solidFill>
-                  <a:srgbClr val="34D399"/>
+                  <a:srgbClr val="927005"/>
                 </a:solidFill>
               </a:defRPr>
             </a:pPr>
@@ -6655,7 +6655,7 @@
             <a:r>
               <a:rPr b="0">
                 <a:solidFill>
-                  <a:srgbClr val="E2E8F0"/>
+                  <a:srgbClr val="1E293B"/>
                 </a:solidFill>
               </a:rPr>
               <a:t>Double-clicking any node triggers an API drill-down to isolate and map neighbor connections.</a:t>
@@ -6668,7 +6668,7 @@
               </a:spcBef>
               <a:defRPr sz="1400" b="1">
                 <a:solidFill>
-                  <a:srgbClr val="34D399"/>
+                  <a:srgbClr val="927005"/>
                 </a:solidFill>
               </a:defRPr>
             </a:pPr>
@@ -6678,7 +6678,7 @@
             <a:r>
               <a:rPr b="0">
                 <a:solidFill>
-                  <a:srgbClr val="E2E8F0"/>
+                  <a:srgbClr val="1E293B"/>
                 </a:solidFill>
               </a:rPr>
               <a:t>Contains 226 unique nodes and 351 active relationships, achieving a dense network ratio of 1.55 edges per node.</a:t>
@@ -6743,7 +6743,7 @@
             <a:avLst/>
           </a:prstGeom>
           <a:solidFill>
-            <a:srgbClr val="0B0F19"/>
+            <a:srgbClr val="FCFAF2"/>
           </a:solidFill>
           <a:ln>
             <a:noFill/>
@@ -6796,7 +6796,7 @@
             <a:pPr>
               <a:defRPr sz="2800" b="1">
                 <a:solidFill>
-                  <a:srgbClr val="38BDF8"/>
+                  <a:srgbClr val="927005"/>
                 </a:solidFill>
                 <a:latin typeface="Arial"/>
               </a:defRPr>
@@ -6832,7 +6832,7 @@
             <a:pPr>
               <a:defRPr sz="1400" b="1">
                 <a:solidFill>
-                  <a:srgbClr val="34D399"/>
+                  <a:srgbClr val="927005"/>
                 </a:solidFill>
               </a:defRPr>
             </a:pPr>
@@ -6842,7 +6842,7 @@
             <a:r>
               <a:rPr b="0">
                 <a:solidFill>
-                  <a:srgbClr val="E2E8F0"/>
+                  <a:srgbClr val="1E293B"/>
                 </a:solidFill>
               </a:rPr>
               <a:t>Retrieves overlapping vectors and tags to answer diagnostic prompts. Every answer details the file source, page index, and confidence score.</a:t>
@@ -6855,7 +6855,7 @@
               </a:spcBef>
               <a:defRPr sz="1400" b="1">
                 <a:solidFill>
-                  <a:srgbClr val="34D399"/>
+                  <a:srgbClr val="927005"/>
                 </a:solidFill>
               </a:defRPr>
             </a:pPr>
@@ -6865,7 +6865,7 @@
             <a:r>
               <a:rPr b="0">
                 <a:solidFill>
-                  <a:srgbClr val="E2E8F0"/>
+                  <a:srgbClr val="1E293B"/>
                 </a:solidFill>
               </a:rPr>
               <a:t>Rotates across three configured Gemini keys to handle rate limits and request throttle errors.</a:t>
@@ -6878,7 +6878,7 @@
               </a:spcBef>
               <a:defRPr sz="1400" b="1">
                 <a:solidFill>
-                  <a:srgbClr val="34D399"/>
+                  <a:srgbClr val="927005"/>
                 </a:solidFill>
               </a:defRPr>
             </a:pPr>
@@ -6888,7 +6888,7 @@
             <a:r>
               <a:rPr b="0">
                 <a:solidFill>
-                  <a:srgbClr val="E2E8F0"/>
+                  <a:srgbClr val="1E293B"/>
                 </a:solidFill>
               </a:rPr>
               <a:t>If keys are missing, the system uses local TF-IDF matching to output citation snippets and answer mock templates offline.</a:t>
@@ -6953,7 +6953,7 @@
             <a:avLst/>
           </a:prstGeom>
           <a:solidFill>
-            <a:srgbClr val="0B0F19"/>
+            <a:srgbClr val="FCFAF2"/>
           </a:solidFill>
           <a:ln>
             <a:noFill/>
@@ -7006,7 +7006,7 @@
             <a:pPr>
               <a:defRPr sz="2800" b="1">
                 <a:solidFill>
-                  <a:srgbClr val="38BDF8"/>
+                  <a:srgbClr val="927005"/>
                 </a:solidFill>
                 <a:latin typeface="Arial"/>
               </a:defRPr>
@@ -7042,7 +7042,7 @@
             <a:pPr>
               <a:defRPr sz="1400" b="1">
                 <a:solidFill>
-                  <a:srgbClr val="34D399"/>
+                  <a:srgbClr val="927005"/>
                 </a:solidFill>
               </a:defRPr>
             </a:pPr>
@@ -7052,7 +7052,7 @@
             <a:r>
               <a:rPr b="0">
                 <a:solidFill>
-                  <a:srgbClr val="E2E8F0"/>
+                  <a:srgbClr val="1E293B"/>
                 </a:solidFill>
               </a:rPr>
               <a:t>Consolidates equipment logs, location, risk rankings, and adjacent graph nodes inside one digital interface.</a:t>
@@ -7065,7 +7065,7 @@
               </a:spcBef>
               <a:defRPr sz="1400" b="1">
                 <a:solidFill>
-                  <a:srgbClr val="34D399"/>
+                  <a:srgbClr val="927005"/>
                 </a:solidFill>
               </a:defRPr>
             </a:pPr>
@@ -7075,7 +7075,7 @@
             <a:r>
               <a:rPr b="0">
                 <a:solidFill>
-                  <a:srgbClr val="E2E8F0"/>
+                  <a:srgbClr val="1E293B"/>
                 </a:solidFill>
               </a:rPr>
               <a:t>Maps historical repair costs and durations, tracking anomalies and repair frequencies.</a:t>
@@ -7088,7 +7088,7 @@
               </a:spcBef>
               <a:defRPr sz="1400" b="1">
                 <a:solidFill>
-                  <a:srgbClr val="34D399"/>
+                  <a:srgbClr val="927005"/>
                 </a:solidFill>
               </a:defRPr>
             </a:pPr>
@@ -7098,10 +7098,10 @@
             <a:r>
               <a:rPr b="0">
                 <a:solidFill>
-                  <a:srgbClr val="E2E8F0"/>
+                  <a:srgbClr val="1E293B"/>
                 </a:solidFill>
               </a:rPr>
-              <a:t>Retrieves safety logs and inspections to reconstruct failure causes (e.g. pressure spikes), displaying verbatim text matches.</a:t>
+              <a:t>Retrieves safety logs and inspections to reconstruct failure causes (e.g. pressure spikes), displaying verbatim text citations.</a:t>
             </a:r>
           </a:p>
         </p:txBody>
@@ -7163,7 +7163,7 @@
             <a:avLst/>
           </a:prstGeom>
           <a:solidFill>
-            <a:srgbClr val="0B0F19"/>
+            <a:srgbClr val="FCFAF2"/>
           </a:solidFill>
           <a:ln>
             <a:noFill/>
@@ -7216,7 +7216,7 @@
             <a:pPr>
               <a:defRPr sz="2800" b="1">
                 <a:solidFill>
-                  <a:srgbClr val="38BDF8"/>
+                  <a:srgbClr val="927005"/>
                 </a:solidFill>
                 <a:latin typeface="Arial"/>
               </a:defRPr>
@@ -7252,7 +7252,7 @@
             <a:pPr>
               <a:defRPr sz="1400" b="1">
                 <a:solidFill>
-                  <a:srgbClr val="34D399"/>
+                  <a:srgbClr val="927005"/>
                 </a:solidFill>
               </a:defRPr>
             </a:pPr>
@@ -7262,7 +7262,7 @@
             <a:r>
               <a:rPr b="0">
                 <a:solidFill>
-                  <a:srgbClr val="E2E8F0"/>
+                  <a:srgbClr val="1E293B"/>
                 </a:solidFill>
               </a:rPr>
               <a:t>Scans ingested manuals against safety rules: pressure vessel certifications, thickness tests, and operator licenses.</a:t>
@@ -7275,7 +7275,7 @@
               </a:spcBef>
               <a:defRPr sz="1400" b="1">
                 <a:solidFill>
-                  <a:srgbClr val="34D399"/>
+                  <a:srgbClr val="927005"/>
                 </a:solidFill>
               </a:defRPr>
             </a:pPr>
@@ -7285,7 +7285,7 @@
             <a:r>
               <a:rPr b="0">
                 <a:solidFill>
-                  <a:srgbClr val="E2E8F0"/>
+                  <a:srgbClr val="1E293B"/>
                 </a:solidFill>
               </a:rPr>
               <a:t>Maps compliance gaps to tasks and safety owners, outlining specific deadlines.</a:t>
@@ -7298,7 +7298,7 @@
               </a:spcBef>
               <a:defRPr sz="1400" b="1">
                 <a:solidFill>
-                  <a:srgbClr val="34D399"/>
+                  <a:srgbClr val="927005"/>
                 </a:solidFill>
               </a:defRPr>
             </a:pPr>
@@ -7308,7 +7308,7 @@
             <a:r>
               <a:rPr b="0">
                 <a:solidFill>
-                  <a:srgbClr val="E2E8F0"/>
+                  <a:srgbClr val="1E293B"/>
                 </a:solidFill>
               </a:rPr>
               <a:t>Completing checklist actions changes gap statuses to compliant, dynamically updating the safety score from 64% to 100% in real-time.</a:t>

</xml_diff>

<commit_message>
fix: resolve z-order overlap bugs by using native PPTX backgrounds
</commit_message>
<xml_diff>
--- a/deliverables/INDUS_BRAIN_AI_Final_Pitch.pptx
+++ b/deliverables/INDUS_BRAIN_AI_Final_Pitch.pptx
@@ -3096,6 +3096,14 @@
 <file path=ppt/slides/slide1.xml><?xml version="1.0" encoding="utf-8"?>
 <p:sld xmlns:a="http://schemas.openxmlformats.org/drawingml/2006/main" xmlns:p="http://schemas.openxmlformats.org/presentationml/2006/main" xmlns:r="http://schemas.openxmlformats.org/officeDocument/2006/relationships">
   <p:cSld>
+    <p:bg>
+      <p:bgPr>
+        <a:solidFill>
+          <a:srgbClr val="FCFAF2"/>
+        </a:solidFill>
+        <a:effectLst/>
+      </p:bgPr>
+    </p:bg>
     <p:spTree>
       <p:nvGrpSpPr>
         <p:cNvPr id="1" name=""/>
@@ -3105,50 +3113,7 @@
       <p:grpSpPr/>
       <p:sp>
         <p:nvSpPr>
-          <p:cNvPr id="2" name="Rectangle 1"/>
-          <p:cNvSpPr/>
-          <p:nvPr/>
-        </p:nvSpPr>
-        <p:spPr>
-          <a:xfrm>
-            <a:off x="0" y="0"/>
-            <a:ext cx="12191695" cy="6858000"/>
-          </a:xfrm>
-          <a:prstGeom prst="rect">
-            <a:avLst/>
-          </a:prstGeom>
-          <a:solidFill>
-            <a:srgbClr val="FCFAF2"/>
-          </a:solidFill>
-          <a:ln>
-            <a:noFill/>
-          </a:ln>
-        </p:spPr>
-        <p:style>
-          <a:lnRef idx="1">
-            <a:schemeClr val="accent1"/>
-          </a:lnRef>
-          <a:fillRef idx="3">
-            <a:schemeClr val="accent1"/>
-          </a:fillRef>
-          <a:effectRef idx="2">
-            <a:schemeClr val="accent1"/>
-          </a:effectRef>
-          <a:fontRef idx="minor">
-            <a:schemeClr val="lt1"/>
-          </a:fontRef>
-        </p:style>
-        <p:txBody>
-          <a:bodyPr rtlCol="0" anchor="ctr"/>
-          <a:lstStyle/>
-          <a:p>
-            <a:pPr algn="ctr"/>
-          </a:p>
-        </p:txBody>
-      </p:sp>
-      <p:sp>
-        <p:nvSpPr>
-          <p:cNvPr id="3" name="TextBox 2"/>
+          <p:cNvPr id="2" name="TextBox 1"/>
           <p:cNvSpPr txBox="1"/>
           <p:nvPr/>
         </p:nvSpPr>
@@ -3168,15 +3133,14 @@
           </a:bodyPr>
           <a:lstStyle/>
           <a:p>
-            <a:pPr algn="ctr">
-              <a:defRPr sz="5400" b="1">
+            <a:pPr algn="ctr"/>
+            <a:r>
+              <a:rPr sz="5400" b="1">
                 <a:solidFill>
                   <a:srgbClr val="927005"/>
                 </a:solidFill>
                 <a:latin typeface="Arial"/>
-              </a:defRPr>
-            </a:pPr>
-            <a:r>
+              </a:rPr>
               <a:t>INDUS BRAIN AI</a:t>
             </a:r>
           </a:p>
@@ -3185,14 +3149,14 @@
               <a:spcBef>
                 <a:spcPts val="2000"/>
               </a:spcBef>
-              <a:defRPr sz="2000" b="1">
+            </a:pPr>
+            <a:r>
+              <a:rPr sz="2000" b="1">
                 <a:solidFill>
                   <a:srgbClr val="1E293B"/>
                 </a:solidFill>
                 <a:latin typeface="Arial"/>
-              </a:defRPr>
-            </a:pPr>
-            <a:r>
+              </a:rPr>
               <a:t>The Unified Asset &amp; Operations Brain for Industrial Enterprise Intelligence</a:t>
             </a:r>
           </a:p>
@@ -3201,14 +3165,14 @@
               <a:spcBef>
                 <a:spcPts val="5000"/>
               </a:spcBef>
-              <a:defRPr sz="1200">
+            </a:pPr>
+            <a:r>
+              <a:rPr sz="1200">
                 <a:solidFill>
                   <a:srgbClr val="64748B"/>
                 </a:solidFill>
                 <a:latin typeface="Arial"/>
-              </a:defRPr>
-            </a:pPr>
-            <a:r>
+              </a:rPr>
               <a:t>ET AI Hackathon 2026 Submission  |  Developed by Team Indus Brain (NITESH100LANKI)</a:t>
             </a:r>
           </a:p>
@@ -3225,6 +3189,14 @@
 <file path=ppt/slides/slide10.xml><?xml version="1.0" encoding="utf-8"?>
 <p:sld xmlns:a="http://schemas.openxmlformats.org/drawingml/2006/main" xmlns:p="http://schemas.openxmlformats.org/presentationml/2006/main" xmlns:r="http://schemas.openxmlformats.org/officeDocument/2006/relationships">
   <p:cSld>
+    <p:bg>
+      <p:bgPr>
+        <a:solidFill>
+          <a:srgbClr val="FCFAF2"/>
+        </a:solidFill>
+        <a:effectLst/>
+      </p:bgPr>
+    </p:bg>
     <p:spTree>
       <p:nvGrpSpPr>
         <p:cNvPr id="1" name=""/>
@@ -3234,50 +3206,7 @@
       <p:grpSpPr/>
       <p:sp>
         <p:nvSpPr>
-          <p:cNvPr id="2" name="Rectangle 1"/>
-          <p:cNvSpPr/>
-          <p:nvPr/>
-        </p:nvSpPr>
-        <p:spPr>
-          <a:xfrm>
-            <a:off x="0" y="0"/>
-            <a:ext cx="12191695" cy="6858000"/>
-          </a:xfrm>
-          <a:prstGeom prst="rect">
-            <a:avLst/>
-          </a:prstGeom>
-          <a:solidFill>
-            <a:srgbClr val="FCFAF2"/>
-          </a:solidFill>
-          <a:ln>
-            <a:noFill/>
-          </a:ln>
-        </p:spPr>
-        <p:style>
-          <a:lnRef idx="1">
-            <a:schemeClr val="accent1"/>
-          </a:lnRef>
-          <a:fillRef idx="3">
-            <a:schemeClr val="accent1"/>
-          </a:fillRef>
-          <a:effectRef idx="2">
-            <a:schemeClr val="accent1"/>
-          </a:effectRef>
-          <a:fontRef idx="minor">
-            <a:schemeClr val="lt1"/>
-          </a:fontRef>
-        </p:style>
-        <p:txBody>
-          <a:bodyPr rtlCol="0" anchor="ctr"/>
-          <a:lstStyle/>
-          <a:p>
-            <a:pPr algn="ctr"/>
-          </a:p>
-        </p:txBody>
-      </p:sp>
-      <p:sp>
-        <p:nvSpPr>
-          <p:cNvPr id="3" name="TextBox 2"/>
+          <p:cNvPr id="2" name="TextBox 1"/>
           <p:cNvSpPr txBox="1"/>
           <p:nvPr/>
         </p:nvSpPr>
@@ -3297,15 +3226,13 @@
           </a:bodyPr>
           <a:lstStyle/>
           <a:p>
-            <a:pPr>
-              <a:defRPr sz="2800" b="1">
+            <a:r>
+              <a:rPr sz="2800" b="1">
                 <a:solidFill>
                   <a:srgbClr val="927005"/>
                 </a:solidFill>
                 <a:latin typeface="Arial"/>
-              </a:defRPr>
-            </a:pPr>
-            <a:r>
+              </a:rPr>
               <a:t>What-If Failure Cascade Simulator</a:t>
             </a:r>
           </a:p>
@@ -3313,7 +3240,7 @@
       </p:sp>
       <p:sp>
         <p:nvSpPr>
-          <p:cNvPr id="4" name="TextBox 3"/>
+          <p:cNvPr id="3" name="TextBox 2"/>
           <p:cNvSpPr txBox="1"/>
           <p:nvPr/>
         </p:nvSpPr>
@@ -3333,21 +3260,21 @@
           </a:bodyPr>
           <a:lstStyle/>
           <a:p>
-            <a:pPr>
-              <a:defRPr sz="1400" b="1">
+            <a:r>
+              <a:rPr sz="1400" b="1">
                 <a:solidFill>
                   <a:srgbClr val="927005"/>
                 </a:solidFill>
-              </a:defRPr>
-            </a:pPr>
-            <a:r>
+                <a:latin typeface="Arial"/>
+              </a:rPr>
               <a:t>• Graph Failure Propagation: </a:t>
             </a:r>
             <a:r>
-              <a:rPr b="0">
+              <a:rPr sz="1400" b="0">
                 <a:solidFill>
                   <a:srgbClr val="1E293B"/>
                 </a:solidFill>
+                <a:latin typeface="Arial"/>
               </a:rPr>
               <a:t>Traverses relational SQLite edges to predict downstream equipment risks based on trigger failures.</a:t>
             </a:r>
@@ -3355,22 +3282,24 @@
           <a:p>
             <a:pPr>
               <a:spcBef>
-                <a:spcPts val="1400"/>
+                <a:spcPts val="1200"/>
               </a:spcBef>
-              <a:defRPr sz="1400" b="1">
+            </a:pPr>
+            <a:r>
+              <a:rPr sz="1400" b="1">
                 <a:solidFill>
                   <a:srgbClr val="927005"/>
                 </a:solidFill>
-              </a:defRPr>
-            </a:pPr>
-            <a:r>
+                <a:latin typeface="Arial"/>
+              </a:rPr>
               <a:t>• Downstream Risk Assessments: </a:t>
             </a:r>
             <a:r>
-              <a:rPr b="0">
+              <a:rPr sz="1400" b="0">
                 <a:solidFill>
                   <a:srgbClr val="1E293B"/>
                 </a:solidFill>
+                <a:latin typeface="Arial"/>
               </a:rPr>
               <a:t>Outputs downtime risks (e.g. 82% elevated risk) and estimates financial impact ($45K loss).</a:t>
             </a:r>
@@ -3378,22 +3307,24 @@
           <a:p>
             <a:pPr>
               <a:spcBef>
-                <a:spcPts val="1400"/>
+                <a:spcPts val="1200"/>
               </a:spcBef>
-              <a:defRPr sz="1400" b="1">
+            </a:pPr>
+            <a:r>
+              <a:rPr sz="1400" b="1">
                 <a:solidFill>
                   <a:srgbClr val="927005"/>
                 </a:solidFill>
-              </a:defRPr>
-            </a:pPr>
-            <a:r>
+                <a:latin typeface="Arial"/>
+              </a:rPr>
               <a:t>• Remedial Recommendations: </a:t>
             </a:r>
             <a:r>
-              <a:rPr b="0">
+              <a:rPr sz="1400" b="0">
                 <a:solidFill>
                   <a:srgbClr val="1E293B"/>
                 </a:solidFill>
+                <a:latin typeface="Arial"/>
               </a:rPr>
               <a:t>Provides immediate corrective measures (e.g. 'Inspect suction valve VLV-204') to halt failure cascades.</a:t>
             </a:r>
@@ -3402,7 +3333,7 @@
       </p:sp>
       <p:pic>
         <p:nvPicPr>
-          <p:cNvPr id="5" name="Picture 4" descr="simulator_screenshot.png"/>
+          <p:cNvPr id="4" name="Picture 3" descr="simulator_screenshot.png"/>
           <p:cNvPicPr>
             <a:picLocks noChangeAspect="1"/>
           </p:cNvPicPr>
@@ -3435,6 +3366,14 @@
 <file path=ppt/slides/slide11.xml><?xml version="1.0" encoding="utf-8"?>
 <p:sld xmlns:a="http://schemas.openxmlformats.org/drawingml/2006/main" xmlns:p="http://schemas.openxmlformats.org/presentationml/2006/main" xmlns:r="http://schemas.openxmlformats.org/officeDocument/2006/relationships">
   <p:cSld>
+    <p:bg>
+      <p:bgPr>
+        <a:solidFill>
+          <a:srgbClr val="FCFAF2"/>
+        </a:solidFill>
+        <a:effectLst/>
+      </p:bgPr>
+    </p:bg>
     <p:spTree>
       <p:nvGrpSpPr>
         <p:cNvPr id="1" name=""/>
@@ -3444,50 +3383,7 @@
       <p:grpSpPr/>
       <p:sp>
         <p:nvSpPr>
-          <p:cNvPr id="2" name="Rectangle 1"/>
-          <p:cNvSpPr/>
-          <p:nvPr/>
-        </p:nvSpPr>
-        <p:spPr>
-          <a:xfrm>
-            <a:off x="0" y="0"/>
-            <a:ext cx="12191695" cy="6858000"/>
-          </a:xfrm>
-          <a:prstGeom prst="rect">
-            <a:avLst/>
-          </a:prstGeom>
-          <a:solidFill>
-            <a:srgbClr val="FCFAF2"/>
-          </a:solidFill>
-          <a:ln>
-            <a:noFill/>
-          </a:ln>
-        </p:spPr>
-        <p:style>
-          <a:lnRef idx="1">
-            <a:schemeClr val="accent1"/>
-          </a:lnRef>
-          <a:fillRef idx="3">
-            <a:schemeClr val="accent1"/>
-          </a:fillRef>
-          <a:effectRef idx="2">
-            <a:schemeClr val="accent1"/>
-          </a:effectRef>
-          <a:fontRef idx="minor">
-            <a:schemeClr val="lt1"/>
-          </a:fontRef>
-        </p:style>
-        <p:txBody>
-          <a:bodyPr rtlCol="0" anchor="ctr"/>
-          <a:lstStyle/>
-          <a:p>
-            <a:pPr algn="ctr"/>
-          </a:p>
-        </p:txBody>
-      </p:sp>
-      <p:sp>
-        <p:nvSpPr>
-          <p:cNvPr id="3" name="TextBox 2"/>
+          <p:cNvPr id="2" name="TextBox 1"/>
           <p:cNvSpPr txBox="1"/>
           <p:nvPr/>
         </p:nvSpPr>
@@ -3507,15 +3403,13 @@
           </a:bodyPr>
           <a:lstStyle/>
           <a:p>
-            <a:pPr>
-              <a:defRPr sz="2800" b="1">
+            <a:r>
+              <a:rPr sz="2800" b="1">
                 <a:solidFill>
                   <a:srgbClr val="927005"/>
                 </a:solidFill>
                 <a:latin typeface="Arial"/>
-              </a:defRPr>
-            </a:pPr>
-            <a:r>
+              </a:rPr>
               <a:t>Performance &amp; Verification Metrics</a:t>
             </a:r>
           </a:p>
@@ -3523,7 +3417,7 @@
       </p:sp>
       <p:sp>
         <p:nvSpPr>
-          <p:cNvPr id="4" name="TextBox 3"/>
+          <p:cNvPr id="3" name="TextBox 2"/>
           <p:cNvSpPr txBox="1"/>
           <p:nvPr/>
         </p:nvSpPr>
@@ -3543,21 +3437,21 @@
           </a:bodyPr>
           <a:lstStyle/>
           <a:p>
-            <a:pPr>
-              <a:defRPr sz="1400" b="1">
+            <a:r>
+              <a:rPr sz="1400" b="1">
                 <a:solidFill>
                   <a:srgbClr val="927005"/>
                 </a:solidFill>
-              </a:defRPr>
-            </a:pPr>
-            <a:r>
+                <a:latin typeface="Arial"/>
+              </a:rPr>
               <a:t>• RAG Grounding Accuracy: </a:t>
             </a:r>
             <a:r>
-              <a:rPr b="0">
+              <a:rPr sz="1400" b="0">
                 <a:solidFill>
                   <a:srgbClr val="1E293B"/>
                 </a:solidFill>
+                <a:latin typeface="Arial"/>
               </a:rPr>
               <a:t>100% verified citation accuracy across seed operating documents. Hallucinations eliminated.</a:t>
             </a:r>
@@ -3567,20 +3461,22 @@
               <a:spcBef>
                 <a:spcPts val="1200"/>
               </a:spcBef>
-              <a:defRPr sz="1400" b="1">
+            </a:pPr>
+            <a:r>
+              <a:rPr sz="1400" b="1">
                 <a:solidFill>
                   <a:srgbClr val="927005"/>
                 </a:solidFill>
-              </a:defRPr>
-            </a:pPr>
-            <a:r>
+                <a:latin typeface="Arial"/>
+              </a:rPr>
               <a:t>• Compliance Rule Coverage: </a:t>
             </a:r>
             <a:r>
-              <a:rPr b="0">
+              <a:rPr sz="1400" b="0">
                 <a:solidFill>
                   <a:srgbClr val="1E293B"/>
                 </a:solidFill>
+                <a:latin typeface="Arial"/>
               </a:rPr>
               <a:t>Evaluated all safety rules across 35 ingested files, generating correct gap flags and remediation alerts.</a:t>
             </a:r>
@@ -3590,20 +3486,22 @@
               <a:spcBef>
                 <a:spcPts val="1200"/>
               </a:spcBef>
-              <a:defRPr sz="1400" b="1">
+            </a:pPr>
+            <a:r>
+              <a:rPr sz="1400" b="1">
                 <a:solidFill>
                   <a:srgbClr val="927005"/>
                 </a:solidFill>
-              </a:defRPr>
-            </a:pPr>
-            <a:r>
+                <a:latin typeface="Arial"/>
+              </a:rPr>
               <a:t>• Interactive Speed Optimization: </a:t>
             </a:r>
             <a:r>
-              <a:rPr b="0">
+              <a:rPr sz="1400" b="0">
                 <a:solidFill>
                   <a:srgbClr val="1E293B"/>
                 </a:solidFill>
+                <a:latin typeface="Arial"/>
               </a:rPr>
               <a:t>Sub-second API response times and 60 FPS graph renders achieved via local SQLite indexes.</a:t>
             </a:r>
@@ -3612,7 +3510,7 @@
       </p:sp>
       <p:graphicFrame>
         <p:nvGraphicFramePr>
-          <p:cNvPr id="5" name="Table 4"/>
+          <p:cNvPr id="4" name="Table 3"/>
           <p:cNvGraphicFramePr>
             <a:graphicFrameLocks noGrp="1"/>
           </p:cNvGraphicFramePr>
@@ -3645,6 +3543,7 @@
                           <a:solidFill>
                             <a:srgbClr val="1E293B"/>
                           </a:solidFill>
+                          <a:latin typeface="Arial"/>
                         </a:defRPr>
                       </a:pPr>
                       <a:r>
@@ -3668,6 +3567,7 @@
                           <a:solidFill>
                             <a:srgbClr val="1E293B"/>
                           </a:solidFill>
+                          <a:latin typeface="Arial"/>
                         </a:defRPr>
                       </a:pPr>
                       <a:r>
@@ -3691,6 +3591,7 @@
                           <a:solidFill>
                             <a:srgbClr val="1E293B"/>
                           </a:solidFill>
+                          <a:latin typeface="Arial"/>
                         </a:defRPr>
                       </a:pPr>
                       <a:r>
@@ -3714,6 +3615,7 @@
                           <a:solidFill>
                             <a:srgbClr val="1E293B"/>
                           </a:solidFill>
+                          <a:latin typeface="Arial"/>
                         </a:defRPr>
                       </a:pPr>
                       <a:r>
@@ -3739,6 +3641,7 @@
                           <a:solidFill>
                             <a:srgbClr val="1E293B"/>
                           </a:solidFill>
+                          <a:latin typeface="Arial"/>
                         </a:defRPr>
                       </a:pPr>
                       <a:r>
@@ -3762,6 +3665,7 @@
                           <a:solidFill>
                             <a:srgbClr val="1E293B"/>
                           </a:solidFill>
+                          <a:latin typeface="Arial"/>
                         </a:defRPr>
                       </a:pPr>
                       <a:r>
@@ -3785,6 +3689,7 @@
                           <a:solidFill>
                             <a:srgbClr val="1E293B"/>
                           </a:solidFill>
+                          <a:latin typeface="Arial"/>
                         </a:defRPr>
                       </a:pPr>
                       <a:r>
@@ -3808,6 +3713,7 @@
                           <a:solidFill>
                             <a:srgbClr val="1E293B"/>
                           </a:solidFill>
+                          <a:latin typeface="Arial"/>
                         </a:defRPr>
                       </a:pPr>
                       <a:r>
@@ -3833,6 +3739,7 @@
                           <a:solidFill>
                             <a:srgbClr val="1E293B"/>
                           </a:solidFill>
+                          <a:latin typeface="Arial"/>
                         </a:defRPr>
                       </a:pPr>
                       <a:r>
@@ -3856,6 +3763,7 @@
                           <a:solidFill>
                             <a:srgbClr val="1E293B"/>
                           </a:solidFill>
+                          <a:latin typeface="Arial"/>
                         </a:defRPr>
                       </a:pPr>
                       <a:r>
@@ -3879,6 +3787,7 @@
                           <a:solidFill>
                             <a:srgbClr val="1E293B"/>
                           </a:solidFill>
+                          <a:latin typeface="Arial"/>
                         </a:defRPr>
                       </a:pPr>
                       <a:r>
@@ -3902,6 +3811,7 @@
                           <a:solidFill>
                             <a:srgbClr val="1E293B"/>
                           </a:solidFill>
+                          <a:latin typeface="Arial"/>
                         </a:defRPr>
                       </a:pPr>
                       <a:r>
@@ -3927,6 +3837,7 @@
                           <a:solidFill>
                             <a:srgbClr val="1E293B"/>
                           </a:solidFill>
+                          <a:latin typeface="Arial"/>
                         </a:defRPr>
                       </a:pPr>
                       <a:r>
@@ -3950,6 +3861,7 @@
                           <a:solidFill>
                             <a:srgbClr val="1E293B"/>
                           </a:solidFill>
+                          <a:latin typeface="Arial"/>
                         </a:defRPr>
                       </a:pPr>
                       <a:r>
@@ -3973,6 +3885,7 @@
                           <a:solidFill>
                             <a:srgbClr val="1E293B"/>
                           </a:solidFill>
+                          <a:latin typeface="Arial"/>
                         </a:defRPr>
                       </a:pPr>
                       <a:r>
@@ -3996,6 +3909,7 @@
                           <a:solidFill>
                             <a:srgbClr val="1E293B"/>
                           </a:solidFill>
+                          <a:latin typeface="Arial"/>
                         </a:defRPr>
                       </a:pPr>
                       <a:r>
@@ -4021,6 +3935,7 @@
                           <a:solidFill>
                             <a:srgbClr val="1E293B"/>
                           </a:solidFill>
+                          <a:latin typeface="Arial"/>
                         </a:defRPr>
                       </a:pPr>
                       <a:r>
@@ -4044,6 +3959,7 @@
                           <a:solidFill>
                             <a:srgbClr val="1E293B"/>
                           </a:solidFill>
+                          <a:latin typeface="Arial"/>
                         </a:defRPr>
                       </a:pPr>
                       <a:r>
@@ -4067,6 +3983,7 @@
                           <a:solidFill>
                             <a:srgbClr val="1E293B"/>
                           </a:solidFill>
+                          <a:latin typeface="Arial"/>
                         </a:defRPr>
                       </a:pPr>
                       <a:r>
@@ -4090,6 +4007,7 @@
                           <a:solidFill>
                             <a:srgbClr val="1E293B"/>
                           </a:solidFill>
+                          <a:latin typeface="Arial"/>
                         </a:defRPr>
                       </a:pPr>
                       <a:r>
@@ -4115,6 +4033,7 @@
                           <a:solidFill>
                             <a:srgbClr val="1E293B"/>
                           </a:solidFill>
+                          <a:latin typeface="Arial"/>
                         </a:defRPr>
                       </a:pPr>
                       <a:r>
@@ -4138,6 +4057,7 @@
                           <a:solidFill>
                             <a:srgbClr val="1E293B"/>
                           </a:solidFill>
+                          <a:latin typeface="Arial"/>
                         </a:defRPr>
                       </a:pPr>
                       <a:r>
@@ -4161,6 +4081,7 @@
                           <a:solidFill>
                             <a:srgbClr val="1E293B"/>
                           </a:solidFill>
+                          <a:latin typeface="Arial"/>
                         </a:defRPr>
                       </a:pPr>
                       <a:r>
@@ -4184,6 +4105,7 @@
                           <a:solidFill>
                             <a:srgbClr val="1E293B"/>
                           </a:solidFill>
+                          <a:latin typeface="Arial"/>
                         </a:defRPr>
                       </a:pPr>
                       <a:r>
@@ -4213,6 +4135,14 @@
 <file path=ppt/slides/slide12.xml><?xml version="1.0" encoding="utf-8"?>
 <p:sld xmlns:a="http://schemas.openxmlformats.org/drawingml/2006/main" xmlns:p="http://schemas.openxmlformats.org/presentationml/2006/main" xmlns:r="http://schemas.openxmlformats.org/officeDocument/2006/relationships">
   <p:cSld>
+    <p:bg>
+      <p:bgPr>
+        <a:solidFill>
+          <a:srgbClr val="FCFAF2"/>
+        </a:solidFill>
+        <a:effectLst/>
+      </p:bgPr>
+    </p:bg>
     <p:spTree>
       <p:nvGrpSpPr>
         <p:cNvPr id="1" name=""/>
@@ -4222,50 +4152,7 @@
       <p:grpSpPr/>
       <p:sp>
         <p:nvSpPr>
-          <p:cNvPr id="2" name="Rectangle 1"/>
-          <p:cNvSpPr/>
-          <p:nvPr/>
-        </p:nvSpPr>
-        <p:spPr>
-          <a:xfrm>
-            <a:off x="0" y="0"/>
-            <a:ext cx="12191695" cy="6858000"/>
-          </a:xfrm>
-          <a:prstGeom prst="rect">
-            <a:avLst/>
-          </a:prstGeom>
-          <a:solidFill>
-            <a:srgbClr val="FCFAF2"/>
-          </a:solidFill>
-          <a:ln>
-            <a:noFill/>
-          </a:ln>
-        </p:spPr>
-        <p:style>
-          <a:lnRef idx="1">
-            <a:schemeClr val="accent1"/>
-          </a:lnRef>
-          <a:fillRef idx="3">
-            <a:schemeClr val="accent1"/>
-          </a:fillRef>
-          <a:effectRef idx="2">
-            <a:schemeClr val="accent1"/>
-          </a:effectRef>
-          <a:fontRef idx="minor">
-            <a:schemeClr val="lt1"/>
-          </a:fontRef>
-        </p:style>
-        <p:txBody>
-          <a:bodyPr rtlCol="0" anchor="ctr"/>
-          <a:lstStyle/>
-          <a:p>
-            <a:pPr algn="ctr"/>
-          </a:p>
-        </p:txBody>
-      </p:sp>
-      <p:sp>
-        <p:nvSpPr>
-          <p:cNvPr id="3" name="TextBox 2"/>
+          <p:cNvPr id="2" name="TextBox 1"/>
           <p:cNvSpPr txBox="1"/>
           <p:nvPr/>
         </p:nvSpPr>
@@ -4285,15 +4172,13 @@
           </a:bodyPr>
           <a:lstStyle/>
           <a:p>
-            <a:pPr>
-              <a:defRPr sz="2800" b="1">
+            <a:r>
+              <a:rPr sz="2800" b="1">
                 <a:solidFill>
                   <a:srgbClr val="927005"/>
                 </a:solidFill>
                 <a:latin typeface="Arial"/>
-              </a:defRPr>
-            </a:pPr>
-            <a:r>
+              </a:rPr>
               <a:t>Business Impact &amp; Enterprise Value</a:t>
             </a:r>
           </a:p>
@@ -4301,7 +4186,7 @@
       </p:sp>
       <p:sp>
         <p:nvSpPr>
-          <p:cNvPr id="4" name="TextBox 3"/>
+          <p:cNvPr id="3" name="TextBox 2"/>
           <p:cNvSpPr txBox="1"/>
           <p:nvPr/>
         </p:nvSpPr>
@@ -4321,22 +4206,21 @@
           </a:bodyPr>
           <a:lstStyle/>
           <a:p>
-            <a:pPr>
-              <a:defRPr sz="1600" b="1">
+            <a:r>
+              <a:rPr sz="1600" b="1">
                 <a:solidFill>
                   <a:srgbClr val="927005"/>
                 </a:solidFill>
                 <a:latin typeface="Arial"/>
-              </a:defRPr>
-            </a:pPr>
-            <a:r>
+              </a:rPr>
               <a:t>✔  35% Reduction in Compliance Overhead: </a:t>
             </a:r>
             <a:r>
-              <a:rPr b="0">
+              <a:rPr sz="1600" b="0">
                 <a:solidFill>
                   <a:srgbClr val="1E293B"/>
                 </a:solidFill>
+                <a:latin typeface="Arial"/>
               </a:rPr>
               <a:t>Replaces manual document search with automated auditing engines and gap alerts, preparing safety coordinators instantly for audits.</a:t>
             </a:r>
@@ -4346,21 +4230,22 @@
               <a:spcBef>
                 <a:spcPts val="1800"/>
               </a:spcBef>
-              <a:defRPr sz="1600" b="1">
+            </a:pPr>
+            <a:r>
+              <a:rPr sz="1600" b="1">
                 <a:solidFill>
                   <a:srgbClr val="927005"/>
                 </a:solidFill>
                 <a:latin typeface="Arial"/>
-              </a:defRPr>
-            </a:pPr>
-            <a:r>
+              </a:rPr>
               <a:t>✔  20% Decline in Troubleshooting Search Time: </a:t>
             </a:r>
             <a:r>
-              <a:rPr b="0">
+              <a:rPr sz="1600" b="0">
                 <a:solidFill>
                   <a:srgbClr val="1E293B"/>
                 </a:solidFill>
+                <a:latin typeface="Arial"/>
               </a:rPr>
               <a:t>Enables field mechanics to retrieve grounded calibration steps in seconds, minimizing shutdown lengths.</a:t>
             </a:r>
@@ -4370,21 +4255,22 @@
               <a:spcBef>
                 <a:spcPts val="1800"/>
               </a:spcBef>
-              <a:defRPr sz="1600" b="1">
+            </a:pPr>
+            <a:r>
+              <a:rPr sz="1600" b="1">
                 <a:solidFill>
                   <a:srgbClr val="927005"/>
                 </a:solidFill>
                 <a:latin typeface="Arial"/>
-              </a:defRPr>
-            </a:pPr>
-            <a:r>
+              </a:rPr>
               <a:t>✔  Reduced Equipment Failures &amp; Safety Gaps: </a:t>
             </a:r>
             <a:r>
-              <a:rPr b="0">
+              <a:rPr sz="1600" b="0">
                 <a:solidFill>
                   <a:srgbClr val="1E293B"/>
                 </a:solidFill>
+                <a:latin typeface="Arial"/>
               </a:rPr>
               <a:t>Identifies cavitation and wear early through root-cause summaries and simulation, reducing incident risks.</a:t>
             </a:r>
@@ -4394,21 +4280,22 @@
               <a:spcBef>
                 <a:spcPts val="1800"/>
               </a:spcBef>
-              <a:defRPr sz="1600" b="1">
+            </a:pPr>
+            <a:r>
+              <a:rPr sz="1600" b="1">
                 <a:solidFill>
                   <a:srgbClr val="927005"/>
                 </a:solidFill>
                 <a:latin typeface="Arial"/>
-              </a:defRPr>
-            </a:pPr>
-            <a:r>
+              </a:rPr>
               <a:t>✔  Continuous Knowledge Preservation: </a:t>
             </a:r>
             <a:r>
-              <a:rPr b="0">
+              <a:rPr sz="1600" b="0">
                 <a:solidFill>
                   <a:srgbClr val="1E293B"/>
                 </a:solidFill>
+                <a:latin typeface="Arial"/>
               </a:rPr>
               <a:t>Captures veteran diagnostic insights within local SQLite knowledge graphs, ensuring seamless team handovers.</a:t>
             </a:r>
@@ -4426,6 +4313,14 @@
 <file path=ppt/slides/slide13.xml><?xml version="1.0" encoding="utf-8"?>
 <p:sld xmlns:a="http://schemas.openxmlformats.org/drawingml/2006/main" xmlns:p="http://schemas.openxmlformats.org/presentationml/2006/main" xmlns:r="http://schemas.openxmlformats.org/officeDocument/2006/relationships">
   <p:cSld>
+    <p:bg>
+      <p:bgPr>
+        <a:solidFill>
+          <a:srgbClr val="FCFAF2"/>
+        </a:solidFill>
+        <a:effectLst/>
+      </p:bgPr>
+    </p:bg>
     <p:spTree>
       <p:nvGrpSpPr>
         <p:cNvPr id="1" name=""/>
@@ -4435,50 +4330,7 @@
       <p:grpSpPr/>
       <p:sp>
         <p:nvSpPr>
-          <p:cNvPr id="2" name="Rectangle 1"/>
-          <p:cNvSpPr/>
-          <p:nvPr/>
-        </p:nvSpPr>
-        <p:spPr>
-          <a:xfrm>
-            <a:off x="0" y="0"/>
-            <a:ext cx="12191695" cy="6858000"/>
-          </a:xfrm>
-          <a:prstGeom prst="rect">
-            <a:avLst/>
-          </a:prstGeom>
-          <a:solidFill>
-            <a:srgbClr val="FCFAF2"/>
-          </a:solidFill>
-          <a:ln>
-            <a:noFill/>
-          </a:ln>
-        </p:spPr>
-        <p:style>
-          <a:lnRef idx="1">
-            <a:schemeClr val="accent1"/>
-          </a:lnRef>
-          <a:fillRef idx="3">
-            <a:schemeClr val="accent1"/>
-          </a:fillRef>
-          <a:effectRef idx="2">
-            <a:schemeClr val="accent1"/>
-          </a:effectRef>
-          <a:fontRef idx="minor">
-            <a:schemeClr val="lt1"/>
-          </a:fontRef>
-        </p:style>
-        <p:txBody>
-          <a:bodyPr rtlCol="0" anchor="ctr"/>
-          <a:lstStyle/>
-          <a:p>
-            <a:pPr algn="ctr"/>
-          </a:p>
-        </p:txBody>
-      </p:sp>
-      <p:sp>
-        <p:nvSpPr>
-          <p:cNvPr id="3" name="TextBox 2"/>
+          <p:cNvPr id="2" name="TextBox 1"/>
           <p:cNvSpPr txBox="1"/>
           <p:nvPr/>
         </p:nvSpPr>
@@ -4498,15 +4350,13 @@
           </a:bodyPr>
           <a:lstStyle/>
           <a:p>
-            <a:pPr>
-              <a:defRPr sz="2800" b="1">
+            <a:r>
+              <a:rPr sz="2800" b="1">
                 <a:solidFill>
                   <a:srgbClr val="927005"/>
                 </a:solidFill>
                 <a:latin typeface="Arial"/>
-              </a:defRPr>
-            </a:pPr>
-            <a:r>
+              </a:rPr>
               <a:t>Enterprise Scalability &amp; Roadmap</a:t>
             </a:r>
           </a:p>
@@ -4514,7 +4364,7 @@
       </p:sp>
       <p:sp>
         <p:nvSpPr>
-          <p:cNvPr id="4" name="TextBox 3"/>
+          <p:cNvPr id="3" name="TextBox 2"/>
           <p:cNvSpPr txBox="1"/>
           <p:nvPr/>
         </p:nvSpPr>
@@ -4534,22 +4384,21 @@
           </a:bodyPr>
           <a:lstStyle/>
           <a:p>
-            <a:pPr>
-              <a:defRPr sz="1500" b="1">
+            <a:r>
+              <a:rPr sz="1500" b="1">
                 <a:solidFill>
                   <a:srgbClr val="927005"/>
                 </a:solidFill>
                 <a:latin typeface="Arial"/>
-              </a:defRPr>
-            </a:pPr>
-            <a:r>
+              </a:rPr>
               <a:t>• Lightweight Local Deployment Core: </a:t>
             </a:r>
             <a:r>
-              <a:rPr b="0">
+              <a:rPr sz="1500" b="0">
                 <a:solidFill>
                   <a:srgbClr val="1E293B"/>
                 </a:solidFill>
+                <a:latin typeface="Arial"/>
               </a:rPr>
               <a:t>The SQLite + TF-IDF fallback configuration ensures portable edge runs without cloud dependencies or high resource footprints.</a:t>
             </a:r>
@@ -4559,21 +4408,22 @@
               <a:spcBef>
                 <a:spcPts val="1600"/>
               </a:spcBef>
-              <a:defRPr sz="1500" b="1">
+            </a:pPr>
+            <a:r>
+              <a:rPr sz="1500" b="1">
                 <a:solidFill>
                   <a:srgbClr val="927005"/>
                 </a:solidFill>
                 <a:latin typeface="Arial"/>
-              </a:defRPr>
-            </a:pPr>
-            <a:r>
+              </a:rPr>
               <a:t>• Docker Containerized Delivery: </a:t>
             </a:r>
             <a:r>
-              <a:rPr b="0">
+              <a:rPr sz="1500" b="0">
                 <a:solidFill>
                   <a:srgbClr val="1E293B"/>
                 </a:solidFill>
+                <a:latin typeface="Arial"/>
               </a:rPr>
               <a:t>Allows single-command container deployments on cloud servers or local plant control units.</a:t>
             </a:r>
@@ -4583,21 +4433,22 @@
               <a:spcBef>
                 <a:spcPts val="1600"/>
               </a:spcBef>
-              <a:defRPr sz="1500" b="1">
+            </a:pPr>
+            <a:r>
+              <a:rPr sz="1500" b="1">
                 <a:solidFill>
                   <a:srgbClr val="927005"/>
                 </a:solidFill>
                 <a:latin typeface="Arial"/>
-              </a:defRPr>
-            </a:pPr>
-            <a:r>
+              </a:rPr>
               <a:t>• Future IoT Telemetry Integration: </a:t>
             </a:r>
             <a:r>
-              <a:rPr b="0">
+              <a:rPr sz="1500" b="0">
                 <a:solidFill>
                   <a:srgbClr val="1E293B"/>
                 </a:solidFill>
+                <a:latin typeface="Arial"/>
               </a:rPr>
               <a:t>The roadmap includes linking live vibration and flow telemetry directly to Digital Twins, automating simulations on sensor threshold alerts.</a:t>
             </a:r>
@@ -4607,21 +4458,22 @@
               <a:spcBef>
                 <a:spcPts val="1600"/>
               </a:spcBef>
-              <a:defRPr sz="1500" b="1">
+            </a:pPr>
+            <a:r>
+              <a:rPr sz="1500" b="1">
                 <a:solidFill>
                   <a:srgbClr val="927005"/>
                 </a:solidFill>
                 <a:latin typeface="Arial"/>
-              </a:defRPr>
-            </a:pPr>
-            <a:r>
+              </a:rPr>
               <a:t>• Vision-Based P&amp;ID Image Parsing: </a:t>
             </a:r>
             <a:r>
-              <a:rPr b="0">
+              <a:rPr sz="1500" b="0">
                 <a:solidFill>
                   <a:srgbClr val="1E293B"/>
                 </a:solidFill>
+                <a:latin typeface="Arial"/>
               </a:rPr>
               <a:t>Integrates computer vision models to read engineering drawings (P&amp;IDs), parsing piping and valves directly into knowledge graph nodes.</a:t>
             </a:r>
@@ -4639,6 +4491,14 @@
 <file path=ppt/slides/slide14.xml><?xml version="1.0" encoding="utf-8"?>
 <p:sld xmlns:a="http://schemas.openxmlformats.org/drawingml/2006/main" xmlns:p="http://schemas.openxmlformats.org/presentationml/2006/main" xmlns:r="http://schemas.openxmlformats.org/officeDocument/2006/relationships">
   <p:cSld>
+    <p:bg>
+      <p:bgPr>
+        <a:solidFill>
+          <a:srgbClr val="FCFAF2"/>
+        </a:solidFill>
+        <a:effectLst/>
+      </p:bgPr>
+    </p:bg>
     <p:spTree>
       <p:nvGrpSpPr>
         <p:cNvPr id="1" name=""/>
@@ -4648,50 +4508,7 @@
       <p:grpSpPr/>
       <p:sp>
         <p:nvSpPr>
-          <p:cNvPr id="2" name="Rectangle 1"/>
-          <p:cNvSpPr/>
-          <p:nvPr/>
-        </p:nvSpPr>
-        <p:spPr>
-          <a:xfrm>
-            <a:off x="0" y="0"/>
-            <a:ext cx="12191695" cy="6858000"/>
-          </a:xfrm>
-          <a:prstGeom prst="rect">
-            <a:avLst/>
-          </a:prstGeom>
-          <a:solidFill>
-            <a:srgbClr val="FCFAF2"/>
-          </a:solidFill>
-          <a:ln>
-            <a:noFill/>
-          </a:ln>
-        </p:spPr>
-        <p:style>
-          <a:lnRef idx="1">
-            <a:schemeClr val="accent1"/>
-          </a:lnRef>
-          <a:fillRef idx="3">
-            <a:schemeClr val="accent1"/>
-          </a:fillRef>
-          <a:effectRef idx="2">
-            <a:schemeClr val="accent1"/>
-          </a:effectRef>
-          <a:fontRef idx="minor">
-            <a:schemeClr val="lt1"/>
-          </a:fontRef>
-        </p:style>
-        <p:txBody>
-          <a:bodyPr rtlCol="0" anchor="ctr"/>
-          <a:lstStyle/>
-          <a:p>
-            <a:pPr algn="ctr"/>
-          </a:p>
-        </p:txBody>
-      </p:sp>
-      <p:sp>
-        <p:nvSpPr>
-          <p:cNvPr id="3" name="TextBox 2"/>
+          <p:cNvPr id="2" name="TextBox 1"/>
           <p:cNvSpPr txBox="1"/>
           <p:nvPr/>
         </p:nvSpPr>
@@ -4711,15 +4528,13 @@
           </a:bodyPr>
           <a:lstStyle/>
           <a:p>
-            <a:pPr>
-              <a:defRPr sz="2800" b="1">
+            <a:r>
+              <a:rPr sz="2800" b="1">
                 <a:solidFill>
                   <a:srgbClr val="927005"/>
                 </a:solidFill>
                 <a:latin typeface="Arial"/>
-              </a:defRPr>
-            </a:pPr>
-            <a:r>
+              </a:rPr>
               <a:t>Competitive Advantage Comparison</a:t>
             </a:r>
           </a:p>
@@ -4727,7 +4542,7 @@
       </p:sp>
       <p:graphicFrame>
         <p:nvGraphicFramePr>
-          <p:cNvPr id="4" name="Table 3"/>
+          <p:cNvPr id="3" name="Table 2"/>
           <p:cNvGraphicFramePr>
             <a:graphicFrameLocks noGrp="1"/>
           </p:cNvGraphicFramePr>
@@ -4760,6 +4575,7 @@
                           <a:solidFill>
                             <a:srgbClr val="1E293B"/>
                           </a:solidFill>
+                          <a:latin typeface="Arial"/>
                         </a:defRPr>
                       </a:pPr>
                       <a:r>
@@ -4783,6 +4599,7 @@
                           <a:solidFill>
                             <a:srgbClr val="1E293B"/>
                           </a:solidFill>
+                          <a:latin typeface="Arial"/>
                         </a:defRPr>
                       </a:pPr>
                       <a:r>
@@ -4806,6 +4623,7 @@
                           <a:solidFill>
                             <a:srgbClr val="1E293B"/>
                           </a:solidFill>
+                          <a:latin typeface="Arial"/>
                         </a:defRPr>
                       </a:pPr>
                       <a:r>
@@ -4829,6 +4647,7 @@
                           <a:solidFill>
                             <a:srgbClr val="1E293B"/>
                           </a:solidFill>
+                          <a:latin typeface="Arial"/>
                         </a:defRPr>
                       </a:pPr>
                       <a:r>
@@ -4854,6 +4673,7 @@
                           <a:solidFill>
                             <a:srgbClr val="1E293B"/>
                           </a:solidFill>
+                          <a:latin typeface="Arial"/>
                         </a:defRPr>
                       </a:pPr>
                       <a:r>
@@ -4877,6 +4697,7 @@
                           <a:solidFill>
                             <a:srgbClr val="1E293B"/>
                           </a:solidFill>
+                          <a:latin typeface="Arial"/>
                         </a:defRPr>
                       </a:pPr>
                       <a:r>
@@ -4900,6 +4721,7 @@
                           <a:solidFill>
                             <a:srgbClr val="1E293B"/>
                           </a:solidFill>
+                          <a:latin typeface="Arial"/>
                         </a:defRPr>
                       </a:pPr>
                       <a:r>
@@ -4923,6 +4745,7 @@
                           <a:solidFill>
                             <a:srgbClr val="1E293B"/>
                           </a:solidFill>
+                          <a:latin typeface="Arial"/>
                         </a:defRPr>
                       </a:pPr>
                       <a:r>
@@ -4948,6 +4771,7 @@
                           <a:solidFill>
                             <a:srgbClr val="1E293B"/>
                           </a:solidFill>
+                          <a:latin typeface="Arial"/>
                         </a:defRPr>
                       </a:pPr>
                       <a:r>
@@ -4971,6 +4795,7 @@
                           <a:solidFill>
                             <a:srgbClr val="1E293B"/>
                           </a:solidFill>
+                          <a:latin typeface="Arial"/>
                         </a:defRPr>
                       </a:pPr>
                       <a:r>
@@ -4994,6 +4819,7 @@
                           <a:solidFill>
                             <a:srgbClr val="1E293B"/>
                           </a:solidFill>
+                          <a:latin typeface="Arial"/>
                         </a:defRPr>
                       </a:pPr>
                       <a:r>
@@ -5017,6 +4843,7 @@
                           <a:solidFill>
                             <a:srgbClr val="1E293B"/>
                           </a:solidFill>
+                          <a:latin typeface="Arial"/>
                         </a:defRPr>
                       </a:pPr>
                       <a:r>
@@ -5042,6 +4869,7 @@
                           <a:solidFill>
                             <a:srgbClr val="1E293B"/>
                           </a:solidFill>
+                          <a:latin typeface="Arial"/>
                         </a:defRPr>
                       </a:pPr>
                       <a:r>
@@ -5065,6 +4893,7 @@
                           <a:solidFill>
                             <a:srgbClr val="1E293B"/>
                           </a:solidFill>
+                          <a:latin typeface="Arial"/>
                         </a:defRPr>
                       </a:pPr>
                       <a:r>
@@ -5088,6 +4917,7 @@
                           <a:solidFill>
                             <a:srgbClr val="1E293B"/>
                           </a:solidFill>
+                          <a:latin typeface="Arial"/>
                         </a:defRPr>
                       </a:pPr>
                       <a:r>
@@ -5111,6 +4941,7 @@
                           <a:solidFill>
                             <a:srgbClr val="1E293B"/>
                           </a:solidFill>
+                          <a:latin typeface="Arial"/>
                         </a:defRPr>
                       </a:pPr>
                       <a:r>
@@ -5140,6 +4971,14 @@
 <file path=ppt/slides/slide15.xml><?xml version="1.0" encoding="utf-8"?>
 <p:sld xmlns:a="http://schemas.openxmlformats.org/drawingml/2006/main" xmlns:p="http://schemas.openxmlformats.org/presentationml/2006/main" xmlns:r="http://schemas.openxmlformats.org/officeDocument/2006/relationships">
   <p:cSld>
+    <p:bg>
+      <p:bgPr>
+        <a:solidFill>
+          <a:srgbClr val="FCFAF2"/>
+        </a:solidFill>
+        <a:effectLst/>
+      </p:bgPr>
+    </p:bg>
     <p:spTree>
       <p:nvGrpSpPr>
         <p:cNvPr id="1" name=""/>
@@ -5149,50 +4988,7 @@
       <p:grpSpPr/>
       <p:sp>
         <p:nvSpPr>
-          <p:cNvPr id="2" name="Rectangle 1"/>
-          <p:cNvSpPr/>
-          <p:nvPr/>
-        </p:nvSpPr>
-        <p:spPr>
-          <a:xfrm>
-            <a:off x="0" y="0"/>
-            <a:ext cx="12191695" cy="6858000"/>
-          </a:xfrm>
-          <a:prstGeom prst="rect">
-            <a:avLst/>
-          </a:prstGeom>
-          <a:solidFill>
-            <a:srgbClr val="FCFAF2"/>
-          </a:solidFill>
-          <a:ln>
-            <a:noFill/>
-          </a:ln>
-        </p:spPr>
-        <p:style>
-          <a:lnRef idx="1">
-            <a:schemeClr val="accent1"/>
-          </a:lnRef>
-          <a:fillRef idx="3">
-            <a:schemeClr val="accent1"/>
-          </a:fillRef>
-          <a:effectRef idx="2">
-            <a:schemeClr val="accent1"/>
-          </a:effectRef>
-          <a:fontRef idx="minor">
-            <a:schemeClr val="lt1"/>
-          </a:fontRef>
-        </p:style>
-        <p:txBody>
-          <a:bodyPr rtlCol="0" anchor="ctr"/>
-          <a:lstStyle/>
-          <a:p>
-            <a:pPr algn="ctr"/>
-          </a:p>
-        </p:txBody>
-      </p:sp>
-      <p:sp>
-        <p:nvSpPr>
-          <p:cNvPr id="3" name="TextBox 2"/>
+          <p:cNvPr id="2" name="TextBox 1"/>
           <p:cNvSpPr txBox="1"/>
           <p:nvPr/>
         </p:nvSpPr>
@@ -5212,15 +5008,13 @@
           </a:bodyPr>
           <a:lstStyle/>
           <a:p>
-            <a:pPr>
-              <a:defRPr sz="2800" b="1">
+            <a:r>
+              <a:rPr sz="2800" b="1">
                 <a:solidFill>
                   <a:srgbClr val="927005"/>
                 </a:solidFill>
                 <a:latin typeface="Arial"/>
-              </a:defRPr>
-            </a:pPr>
-            <a:r>
+              </a:rPr>
               <a:t>Why INDUS BRAIN AI Wins</a:t>
             </a:r>
           </a:p>
@@ -5228,7 +5022,7 @@
       </p:sp>
       <p:sp>
         <p:nvSpPr>
-          <p:cNvPr id="4" name="TextBox 3"/>
+          <p:cNvPr id="3" name="TextBox 2"/>
           <p:cNvSpPr txBox="1"/>
           <p:nvPr/>
         </p:nvSpPr>
@@ -5248,22 +5042,21 @@
           </a:bodyPr>
           <a:lstStyle/>
           <a:p>
-            <a:pPr>
-              <a:defRPr sz="1500" b="1">
+            <a:r>
+              <a:rPr sz="1500" b="1">
                 <a:solidFill>
                   <a:srgbClr val="927005"/>
                 </a:solidFill>
                 <a:latin typeface="Arial"/>
-              </a:defRPr>
-            </a:pPr>
-            <a:r>
+              </a:rPr>
               <a:t>• Innovation Core: </a:t>
             </a:r>
             <a:r>
-              <a:rPr b="0">
+              <a:rPr sz="1500" b="0">
                 <a:solidFill>
                   <a:srgbClr val="1E293B"/>
                 </a:solidFill>
+                <a:latin typeface="Arial"/>
               </a:rPr>
               <a:t>Combines semantic text search (RAG) with SQLite relational graph layers to offer comprehensive operational insights.</a:t>
             </a:r>
@@ -5273,21 +5066,22 @@
               <a:spcBef>
                 <a:spcPts val="1400"/>
               </a:spcBef>
-              <a:defRPr sz="1500" b="1">
+            </a:pPr>
+            <a:r>
+              <a:rPr sz="1500" b="1">
                 <a:solidFill>
                   <a:srgbClr val="927005"/>
                 </a:solidFill>
                 <a:latin typeface="Arial"/>
-              </a:defRPr>
-            </a:pPr>
-            <a:r>
+              </a:rPr>
               <a:t>• Tangible Business Value: </a:t>
             </a:r>
             <a:r>
-              <a:rPr b="0">
+              <a:rPr sz="1500" b="0">
                 <a:solidFill>
                   <a:srgbClr val="1E293B"/>
                 </a:solidFill>
+                <a:latin typeface="Arial"/>
               </a:rPr>
               <a:t>Addresses high-cost industrial downtime ($45K/hr) and automates complex regulatory compliance workflows.</a:t>
             </a:r>
@@ -5297,21 +5091,22 @@
               <a:spcBef>
                 <a:spcPts val="1400"/>
               </a:spcBef>
-              <a:defRPr sz="1500" b="1">
+            </a:pPr>
+            <a:r>
+              <a:rPr sz="1500" b="1">
                 <a:solidFill>
                   <a:srgbClr val="927005"/>
                 </a:solidFill>
                 <a:latin typeface="Arial"/>
-              </a:defRPr>
-            </a:pPr>
-            <a:r>
+              </a:rPr>
               <a:t>• Engineering Depth: </a:t>
             </a:r>
             <a:r>
-              <a:rPr b="0">
+              <a:rPr sz="1500" b="0">
                 <a:solidFill>
                   <a:srgbClr val="1E293B"/>
                 </a:solidFill>
+                <a:latin typeface="Arial"/>
               </a:rPr>
               <a:t>Delivers robust offline fallbacks, key rotations, and custom parsers packed into a lightweight edge profile.</a:t>
             </a:r>
@@ -5321,21 +5116,22 @@
               <a:spcBef>
                 <a:spcPts val="1400"/>
               </a:spcBef>
-              <a:defRPr sz="1500" b="1">
+            </a:pPr>
+            <a:r>
+              <a:rPr sz="1500" b="1">
                 <a:solidFill>
                   <a:srgbClr val="927005"/>
                 </a:solidFill>
                 <a:latin typeface="Arial"/>
-              </a:defRPr>
-            </a:pPr>
-            <a:r>
+              </a:rPr>
               <a:t>• Edge Ready Design: </a:t>
             </a:r>
             <a:r>
-              <a:rPr b="0">
+              <a:rPr sz="1500" b="0">
                 <a:solidFill>
                   <a:srgbClr val="1E293B"/>
                 </a:solidFill>
+                <a:latin typeface="Arial"/>
               </a:rPr>
               <a:t>Decoupled container builds (FastAPI, React, SQLite) ensure scalable edge deployment out-of-the-box.</a:t>
             </a:r>
@@ -5345,21 +5141,22 @@
               <a:spcBef>
                 <a:spcPts val="1400"/>
               </a:spcBef>
-              <a:defRPr sz="1500" b="1">
+            </a:pPr>
+            <a:r>
+              <a:rPr sz="1500" b="1">
                 <a:solidFill>
                   <a:srgbClr val="927005"/>
                 </a:solidFill>
                 <a:latin typeface="Arial"/>
-              </a:defRPr>
-            </a:pPr>
-            <a:r>
+              </a:rPr>
               <a:t>• Stunning UX Excellence: </a:t>
             </a:r>
             <a:r>
-              <a:rPr b="0">
+              <a:rPr sz="1500" b="0">
                 <a:solidFill>
                   <a:srgbClr val="1E293B"/>
                 </a:solidFill>
+                <a:latin typeface="Arial"/>
               </a:rPr>
               <a:t>Features an interactive physics graph and citation slides, putting details at operators' fingertips.</a:t>
             </a:r>
@@ -5377,6 +5174,14 @@
 <file path=ppt/slides/slide16.xml><?xml version="1.0" encoding="utf-8"?>
 <p:sld xmlns:a="http://schemas.openxmlformats.org/drawingml/2006/main" xmlns:p="http://schemas.openxmlformats.org/presentationml/2006/main" xmlns:r="http://schemas.openxmlformats.org/officeDocument/2006/relationships">
   <p:cSld>
+    <p:bg>
+      <p:bgPr>
+        <a:solidFill>
+          <a:srgbClr val="FCFAF2"/>
+        </a:solidFill>
+        <a:effectLst/>
+      </p:bgPr>
+    </p:bg>
     <p:spTree>
       <p:nvGrpSpPr>
         <p:cNvPr id="1" name=""/>
@@ -5386,50 +5191,7 @@
       <p:grpSpPr/>
       <p:sp>
         <p:nvSpPr>
-          <p:cNvPr id="2" name="Rectangle 1"/>
-          <p:cNvSpPr/>
-          <p:nvPr/>
-        </p:nvSpPr>
-        <p:spPr>
-          <a:xfrm>
-            <a:off x="0" y="0"/>
-            <a:ext cx="12191695" cy="6858000"/>
-          </a:xfrm>
-          <a:prstGeom prst="rect">
-            <a:avLst/>
-          </a:prstGeom>
-          <a:solidFill>
-            <a:srgbClr val="FCFAF2"/>
-          </a:solidFill>
-          <a:ln>
-            <a:noFill/>
-          </a:ln>
-        </p:spPr>
-        <p:style>
-          <a:lnRef idx="1">
-            <a:schemeClr val="accent1"/>
-          </a:lnRef>
-          <a:fillRef idx="3">
-            <a:schemeClr val="accent1"/>
-          </a:fillRef>
-          <a:effectRef idx="2">
-            <a:schemeClr val="accent1"/>
-          </a:effectRef>
-          <a:fontRef idx="minor">
-            <a:schemeClr val="lt1"/>
-          </a:fontRef>
-        </p:style>
-        <p:txBody>
-          <a:bodyPr rtlCol="0" anchor="ctr"/>
-          <a:lstStyle/>
-          <a:p>
-            <a:pPr algn="ctr"/>
-          </a:p>
-        </p:txBody>
-      </p:sp>
-      <p:sp>
-        <p:nvSpPr>
-          <p:cNvPr id="3" name="TextBox 2"/>
+          <p:cNvPr id="2" name="TextBox 1"/>
           <p:cNvSpPr txBox="1"/>
           <p:nvPr/>
         </p:nvSpPr>
@@ -5449,15 +5211,14 @@
           </a:bodyPr>
           <a:lstStyle/>
           <a:p>
-            <a:pPr algn="ctr">
-              <a:defRPr sz="5600" b="1">
+            <a:pPr algn="ctr"/>
+            <a:r>
+              <a:rPr sz="5600" b="1">
                 <a:solidFill>
                   <a:srgbClr val="927005"/>
                 </a:solidFill>
                 <a:latin typeface="Arial"/>
-              </a:defRPr>
-            </a:pPr>
-            <a:r>
+              </a:rPr>
               <a:t>THANK YOU</a:t>
             </a:r>
           </a:p>
@@ -5466,14 +5227,14 @@
               <a:spcBef>
                 <a:spcPts val="2000"/>
               </a:spcBef>
-              <a:defRPr sz="2000" b="1">
+            </a:pPr>
+            <a:r>
+              <a:rPr sz="2000" b="1">
                 <a:solidFill>
                   <a:srgbClr val="1E293B"/>
                 </a:solidFill>
                 <a:latin typeface="Arial"/>
-              </a:defRPr>
-            </a:pPr>
-            <a:r>
+              </a:rPr>
               <a:t>INDUS BRAIN AI  |  Live Demo Ready</a:t>
             </a:r>
           </a:p>
@@ -5482,14 +5243,14 @@
               <a:spcBef>
                 <a:spcPts val="4000"/>
               </a:spcBef>
-              <a:defRPr sz="1400">
+            </a:pPr>
+            <a:r>
+              <a:rPr sz="1400">
                 <a:solidFill>
                   <a:srgbClr val="64748B"/>
                 </a:solidFill>
                 <a:latin typeface="Arial"/>
-              </a:defRPr>
-            </a:pPr>
-            <a:r>
+              </a:rPr>
               <a:t>Open http://localhost:8000 to interact with the Operations Brain.</a:t>
             </a:r>
           </a:p>
@@ -5506,6 +5267,14 @@
 <file path=ppt/slides/slide2.xml><?xml version="1.0" encoding="utf-8"?>
 <p:sld xmlns:a="http://schemas.openxmlformats.org/drawingml/2006/main" xmlns:p="http://schemas.openxmlformats.org/presentationml/2006/main" xmlns:r="http://schemas.openxmlformats.org/officeDocument/2006/relationships">
   <p:cSld>
+    <p:bg>
+      <p:bgPr>
+        <a:solidFill>
+          <a:srgbClr val="FCFAF2"/>
+        </a:solidFill>
+        <a:effectLst/>
+      </p:bgPr>
+    </p:bg>
     <p:spTree>
       <p:nvGrpSpPr>
         <p:cNvPr id="1" name=""/>
@@ -5515,50 +5284,7 @@
       <p:grpSpPr/>
       <p:sp>
         <p:nvSpPr>
-          <p:cNvPr id="2" name="Rectangle 1"/>
-          <p:cNvSpPr/>
-          <p:nvPr/>
-        </p:nvSpPr>
-        <p:spPr>
-          <a:xfrm>
-            <a:off x="0" y="0"/>
-            <a:ext cx="12191695" cy="6858000"/>
-          </a:xfrm>
-          <a:prstGeom prst="rect">
-            <a:avLst/>
-          </a:prstGeom>
-          <a:solidFill>
-            <a:srgbClr val="FCFAF2"/>
-          </a:solidFill>
-          <a:ln>
-            <a:noFill/>
-          </a:ln>
-        </p:spPr>
-        <p:style>
-          <a:lnRef idx="1">
-            <a:schemeClr val="accent1"/>
-          </a:lnRef>
-          <a:fillRef idx="3">
-            <a:schemeClr val="accent1"/>
-          </a:fillRef>
-          <a:effectRef idx="2">
-            <a:schemeClr val="accent1"/>
-          </a:effectRef>
-          <a:fontRef idx="minor">
-            <a:schemeClr val="lt1"/>
-          </a:fontRef>
-        </p:style>
-        <p:txBody>
-          <a:bodyPr rtlCol="0" anchor="ctr"/>
-          <a:lstStyle/>
-          <a:p>
-            <a:pPr algn="ctr"/>
-          </a:p>
-        </p:txBody>
-      </p:sp>
-      <p:sp>
-        <p:nvSpPr>
-          <p:cNvPr id="3" name="TextBox 2"/>
+          <p:cNvPr id="2" name="TextBox 1"/>
           <p:cNvSpPr txBox="1"/>
           <p:nvPr/>
         </p:nvSpPr>
@@ -5578,15 +5304,13 @@
           </a:bodyPr>
           <a:lstStyle/>
           <a:p>
-            <a:pPr>
-              <a:defRPr sz="2800" b="1">
+            <a:r>
+              <a:rPr sz="2800" b="1">
                 <a:solidFill>
                   <a:srgbClr val="927005"/>
                 </a:solidFill>
                 <a:latin typeface="Arial"/>
-              </a:defRPr>
-            </a:pPr>
-            <a:r>
+              </a:rPr>
               <a:t>The Problem: Unstructured Industrial Silos</a:t>
             </a:r>
           </a:p>
@@ -5594,7 +5318,7 @@
       </p:sp>
       <p:sp>
         <p:nvSpPr>
-          <p:cNvPr id="4" name="TextBox 3"/>
+          <p:cNvPr id="3" name="TextBox 2"/>
           <p:cNvSpPr txBox="1"/>
           <p:nvPr/>
         </p:nvSpPr>
@@ -5614,22 +5338,21 @@
           </a:bodyPr>
           <a:lstStyle/>
           <a:p>
-            <a:pPr>
-              <a:defRPr sz="1600" b="1">
+            <a:r>
+              <a:rPr sz="1600" b="1">
                 <a:solidFill>
                   <a:srgbClr val="927005"/>
                 </a:solidFill>
                 <a:latin typeface="Arial"/>
-              </a:defRPr>
-            </a:pPr>
-            <a:r>
+              </a:rPr>
               <a:t>• Knowledge Fragmentation: </a:t>
             </a:r>
             <a:r>
-              <a:rPr b="0">
+              <a:rPr sz="1600" b="0">
                 <a:solidFill>
                   <a:srgbClr val="1E293B"/>
                 </a:solidFill>
+                <a:latin typeface="Arial"/>
               </a:rPr>
               <a:t>Procedures, checklists, audit reports, and manuals are scattered in separate folders and file formats.</a:t>
             </a:r>
@@ -5639,21 +5362,22 @@
               <a:spcBef>
                 <a:spcPts val="1400"/>
               </a:spcBef>
-              <a:defRPr sz="1600" b="1">
+            </a:pPr>
+            <a:r>
+              <a:rPr sz="1600" b="1">
                 <a:solidFill>
                   <a:srgbClr val="927005"/>
                 </a:solidFill>
                 <a:latin typeface="Arial"/>
-              </a:defRPr>
-            </a:pPr>
-            <a:r>
+              </a:rPr>
               <a:t>• Downtime Severity: </a:t>
             </a:r>
             <a:r>
-              <a:rPr b="0">
+              <a:rPr sz="1600" b="0">
                 <a:solidFill>
                   <a:srgbClr val="1E293B"/>
                 </a:solidFill>
+                <a:latin typeface="Arial"/>
               </a:rPr>
               <a:t>Delays in technical retrieval lengthen troubleshooting times, costing up to $45,000 per hour of shutdown.</a:t>
             </a:r>
@@ -5663,21 +5387,22 @@
               <a:spcBef>
                 <a:spcPts val="1400"/>
               </a:spcBef>
-              <a:defRPr sz="1600" b="1">
+            </a:pPr>
+            <a:r>
+              <a:rPr sz="1600" b="1">
                 <a:solidFill>
                   <a:srgbClr val="927005"/>
                 </a:solidFill>
                 <a:latin typeface="Arial"/>
-              </a:defRPr>
-            </a:pPr>
-            <a:r>
+              </a:rPr>
               <a:t>• Compliance Gaps: </a:t>
             </a:r>
             <a:r>
-              <a:rPr b="0">
+              <a:rPr sz="1600" b="0">
                 <a:solidFill>
                   <a:srgbClr val="1E293B"/>
                 </a:solidFill>
+                <a:latin typeface="Arial"/>
               </a:rPr>
               <a:t>Manual auditing fails to detect expired certifications or skipped maintenance tasks, creating regulatory and safety risks.</a:t>
             </a:r>
@@ -5687,21 +5412,22 @@
               <a:spcBef>
                 <a:spcPts val="1400"/>
               </a:spcBef>
-              <a:defRPr sz="1600" b="1">
+            </a:pPr>
+            <a:r>
+              <a:rPr sz="1600" b="1">
                 <a:solidFill>
                   <a:srgbClr val="927005"/>
                 </a:solidFill>
                 <a:latin typeface="Arial"/>
-              </a:defRPr>
-            </a:pPr>
-            <a:r>
+              </a:rPr>
               <a:t>• Implicit Knowledge Loss: </a:t>
             </a:r>
             <a:r>
-              <a:rPr b="0">
+              <a:rPr sz="1600" b="0">
                 <a:solidFill>
                   <a:srgbClr val="1E293B"/>
                 </a:solidFill>
+                <a:latin typeface="Arial"/>
               </a:rPr>
               <a:t>Expert tribal knowledge escapes as senior operators retire, leaving no digitized diagnostic reference.</a:t>
             </a:r>
@@ -5710,7 +5436,7 @@
       </p:sp>
       <p:sp>
         <p:nvSpPr>
-          <p:cNvPr id="5" name="TextBox 4"/>
+          <p:cNvPr id="4" name="TextBox 3"/>
           <p:cNvSpPr txBox="1"/>
           <p:nvPr/>
         </p:nvSpPr>
@@ -5730,26 +5456,26 @@
           </a:bodyPr>
           <a:lstStyle/>
           <a:p>
-            <a:pPr algn="ctr">
-              <a:defRPr sz="5600" b="1">
+            <a:pPr algn="ctr"/>
+            <a:r>
+              <a:rPr sz="5600" b="1">
                 <a:solidFill>
                   <a:srgbClr val="B91C1C"/>
                 </a:solidFill>
-              </a:defRPr>
-            </a:pPr>
-            <a:r>
+                <a:latin typeface="Arial"/>
+              </a:rPr>
               <a:t>$45,000+</a:t>
             </a:r>
           </a:p>
           <a:p>
-            <a:pPr algn="ctr">
-              <a:defRPr sz="1600" b="1">
+            <a:pPr algn="ctr"/>
+            <a:r>
+              <a:rPr sz="1600" b="1">
                 <a:solidFill>
                   <a:srgbClr val="1E293B"/>
                 </a:solidFill>
-              </a:defRPr>
-            </a:pPr>
-            <a:r>
+                <a:latin typeface="Arial"/>
+              </a:rPr>
               <a:t>Unplanned Downtime Cost per Hour</a:t>
             </a:r>
           </a:p>
@@ -5758,13 +5484,14 @@
               <a:spcBef>
                 <a:spcPts val="2500"/>
               </a:spcBef>
-              <a:defRPr sz="1400">
+            </a:pPr>
+            <a:r>
+              <a:rPr sz="1400">
                 <a:solidFill>
                   <a:srgbClr val="64748B"/>
                 </a:solidFill>
-              </a:defRPr>
-            </a:pPr>
-            <a:r>
+                <a:latin typeface="Arial"/>
+              </a:rPr>
               <a:t>45 Minutes Avg. Search Time per Procedure</a:t>
             </a:r>
           </a:p>
@@ -5781,6 +5508,14 @@
 <file path=ppt/slides/slide3.xml><?xml version="1.0" encoding="utf-8"?>
 <p:sld xmlns:a="http://schemas.openxmlformats.org/drawingml/2006/main" xmlns:p="http://schemas.openxmlformats.org/presentationml/2006/main" xmlns:r="http://schemas.openxmlformats.org/officeDocument/2006/relationships">
   <p:cSld>
+    <p:bg>
+      <p:bgPr>
+        <a:solidFill>
+          <a:srgbClr val="FCFAF2"/>
+        </a:solidFill>
+        <a:effectLst/>
+      </p:bgPr>
+    </p:bg>
     <p:spTree>
       <p:nvGrpSpPr>
         <p:cNvPr id="1" name=""/>
@@ -5790,50 +5525,7 @@
       <p:grpSpPr/>
       <p:sp>
         <p:nvSpPr>
-          <p:cNvPr id="2" name="Rectangle 1"/>
-          <p:cNvSpPr/>
-          <p:nvPr/>
-        </p:nvSpPr>
-        <p:spPr>
-          <a:xfrm>
-            <a:off x="0" y="0"/>
-            <a:ext cx="12191695" cy="6858000"/>
-          </a:xfrm>
-          <a:prstGeom prst="rect">
-            <a:avLst/>
-          </a:prstGeom>
-          <a:solidFill>
-            <a:srgbClr val="FCFAF2"/>
-          </a:solidFill>
-          <a:ln>
-            <a:noFill/>
-          </a:ln>
-        </p:spPr>
-        <p:style>
-          <a:lnRef idx="1">
-            <a:schemeClr val="accent1"/>
-          </a:lnRef>
-          <a:fillRef idx="3">
-            <a:schemeClr val="accent1"/>
-          </a:fillRef>
-          <a:effectRef idx="2">
-            <a:schemeClr val="accent1"/>
-          </a:effectRef>
-          <a:fontRef idx="minor">
-            <a:schemeClr val="lt1"/>
-          </a:fontRef>
-        </p:style>
-        <p:txBody>
-          <a:bodyPr rtlCol="0" anchor="ctr"/>
-          <a:lstStyle/>
-          <a:p>
-            <a:pPr algn="ctr"/>
-          </a:p>
-        </p:txBody>
-      </p:sp>
-      <p:sp>
-        <p:nvSpPr>
-          <p:cNvPr id="3" name="TextBox 2"/>
+          <p:cNvPr id="2" name="TextBox 1"/>
           <p:cNvSpPr txBox="1"/>
           <p:nvPr/>
         </p:nvSpPr>
@@ -5853,15 +5545,13 @@
           </a:bodyPr>
           <a:lstStyle/>
           <a:p>
-            <a:pPr>
-              <a:defRPr sz="2800" b="1">
+            <a:r>
+              <a:rPr sz="2800" b="1">
                 <a:solidFill>
                   <a:srgbClr val="927005"/>
                 </a:solidFill>
                 <a:latin typeface="Arial"/>
-              </a:defRPr>
-            </a:pPr>
-            <a:r>
+              </a:rPr>
               <a:t>Industry Impact &amp; Operational Inefficiencies</a:t>
             </a:r>
           </a:p>
@@ -5869,7 +5559,7 @@
       </p:sp>
       <p:sp>
         <p:nvSpPr>
-          <p:cNvPr id="4" name="TextBox 3"/>
+          <p:cNvPr id="3" name="TextBox 2"/>
           <p:cNvSpPr txBox="1"/>
           <p:nvPr/>
         </p:nvSpPr>
@@ -5889,22 +5579,21 @@
           </a:bodyPr>
           <a:lstStyle/>
           <a:p>
-            <a:pPr>
-              <a:defRPr sz="1600" b="1">
+            <a:r>
+              <a:rPr sz="1600" b="1">
                 <a:solidFill>
                   <a:srgbClr val="927005"/>
                 </a:solidFill>
                 <a:latin typeface="Arial"/>
-              </a:defRPr>
-            </a:pPr>
-            <a:r>
+              </a:rPr>
               <a:t>• Asset Intensive Complexes: </a:t>
             </a:r>
             <a:r>
-              <a:rPr b="0">
+              <a:rPr sz="1600" b="0">
                 <a:solidFill>
                   <a:srgbClr val="1E293B"/>
                 </a:solidFill>
+                <a:latin typeface="Arial"/>
               </a:rPr>
               <a:t>Power complexes, chemical plants, and oil refineries operate under extreme hazard conditions where manual diagnostics trigger delayed reaction times.</a:t>
             </a:r>
@@ -5914,21 +5603,22 @@
               <a:spcBef>
                 <a:spcPts val="1600"/>
               </a:spcBef>
-              <a:defRPr sz="1600" b="1">
+            </a:pPr>
+            <a:r>
+              <a:rPr sz="1600" b="1">
                 <a:solidFill>
                   <a:srgbClr val="927005"/>
                 </a:solidFill>
                 <a:latin typeface="Arial"/>
-              </a:defRPr>
-            </a:pPr>
-            <a:r>
+              </a:rPr>
               <a:t>• Regulatory &amp; Compliance Burden: </a:t>
             </a:r>
             <a:r>
-              <a:rPr b="0">
+              <a:rPr sz="1600" b="0">
                 <a:solidFill>
                   <a:srgbClr val="1E293B"/>
                 </a:solidFill>
+                <a:latin typeface="Arial"/>
               </a:rPr>
               <a:t>Annual compliance audits require manual evaluation of safety standards. Failing an audit incurs severe penalties and risks operational freezes.</a:t>
             </a:r>
@@ -5938,21 +5628,22 @@
               <a:spcBef>
                 <a:spcPts val="1600"/>
               </a:spcBef>
-              <a:defRPr sz="1600" b="1">
+            </a:pPr>
+            <a:r>
+              <a:rPr sz="1600" b="1">
                 <a:solidFill>
                   <a:srgbClr val="927005"/>
                 </a:solidFill>
                 <a:latin typeface="Arial"/>
-              </a:defRPr>
-            </a:pPr>
-            <a:r>
+              </a:rPr>
               <a:t>• Maintenance Inefficiencies: </a:t>
             </a:r>
             <a:r>
-              <a:rPr b="0">
+              <a:rPr sz="1600" b="0">
                 <a:solidFill>
                   <a:srgbClr val="1E293B"/>
                 </a:solidFill>
+                <a:latin typeface="Arial"/>
               </a:rPr>
               <a:t>Without contextual search, mechanics perform redundant trial-and-error troubleshooting on heavy machinery.</a:t>
             </a:r>
@@ -5961,7 +5652,7 @@
       </p:sp>
       <p:sp>
         <p:nvSpPr>
-          <p:cNvPr id="5" name="TextBox 4"/>
+          <p:cNvPr id="4" name="TextBox 3"/>
           <p:cNvSpPr txBox="1"/>
           <p:nvPr/>
         </p:nvSpPr>
@@ -5981,14 +5672,13 @@
           </a:bodyPr>
           <a:lstStyle/>
           <a:p>
-            <a:pPr>
-              <a:defRPr sz="1600" b="1">
+            <a:r>
+              <a:rPr sz="1600" b="1">
                 <a:solidFill>
                   <a:srgbClr val="927005"/>
                 </a:solidFill>
-              </a:defRPr>
-            </a:pPr>
-            <a:r>
+                <a:latin typeface="Arial"/>
+              </a:rPr>
               <a:t>TARGET SECTORS</a:t>
             </a:r>
           </a:p>
@@ -5997,13 +5687,14 @@
               <a:spcBef>
                 <a:spcPts val="1200"/>
               </a:spcBef>
-              <a:defRPr sz="1500">
+            </a:pPr>
+            <a:r>
+              <a:rPr sz="1500">
                 <a:solidFill>
                   <a:srgbClr val="1E293B"/>
                 </a:solidFill>
-              </a:defRPr>
-            </a:pPr>
-            <a:r>
+                <a:latin typeface="Arial"/>
+              </a:rPr>
               <a:t>✔  Power Generation &amp; Utilities</a:t>
             </a:r>
           </a:p>
@@ -6012,13 +5703,14 @@
               <a:spcBef>
                 <a:spcPts val="1200"/>
               </a:spcBef>
-              <a:defRPr sz="1500">
+            </a:pPr>
+            <a:r>
+              <a:rPr sz="1500">
                 <a:solidFill>
                   <a:srgbClr val="1E293B"/>
                 </a:solidFill>
-              </a:defRPr>
-            </a:pPr>
-            <a:r>
+                <a:latin typeface="Arial"/>
+              </a:rPr>
               <a:t>✔  Chemical &amp; Petrochemical Processing</a:t>
             </a:r>
           </a:p>
@@ -6027,13 +5719,14 @@
               <a:spcBef>
                 <a:spcPts val="1200"/>
               </a:spcBef>
-              <a:defRPr sz="1500">
+            </a:pPr>
+            <a:r>
+              <a:rPr sz="1500">
                 <a:solidFill>
                   <a:srgbClr val="1E293B"/>
                 </a:solidFill>
-              </a:defRPr>
-            </a:pPr>
-            <a:r>
+                <a:latin typeface="Arial"/>
+              </a:rPr>
               <a:t>✔  Oil &amp; Gas Refineries</a:t>
             </a:r>
           </a:p>
@@ -6042,13 +5735,14 @@
               <a:spcBef>
                 <a:spcPts val="1200"/>
               </a:spcBef>
-              <a:defRPr sz="1500">
+            </a:pPr>
+            <a:r>
+              <a:rPr sz="1500">
                 <a:solidFill>
                   <a:srgbClr val="1E293B"/>
                 </a:solidFill>
-              </a:defRPr>
-            </a:pPr>
-            <a:r>
+                <a:latin typeface="Arial"/>
+              </a:rPr>
               <a:t>✔  Heavy Metals &amp; Mining Facilities</a:t>
             </a:r>
           </a:p>
@@ -6065,6 +5759,14 @@
 <file path=ppt/slides/slide4.xml><?xml version="1.0" encoding="utf-8"?>
 <p:sld xmlns:a="http://schemas.openxmlformats.org/drawingml/2006/main" xmlns:p="http://schemas.openxmlformats.org/presentationml/2006/main" xmlns:r="http://schemas.openxmlformats.org/officeDocument/2006/relationships">
   <p:cSld>
+    <p:bg>
+      <p:bgPr>
+        <a:solidFill>
+          <a:srgbClr val="FCFAF2"/>
+        </a:solidFill>
+        <a:effectLst/>
+      </p:bgPr>
+    </p:bg>
     <p:spTree>
       <p:nvGrpSpPr>
         <p:cNvPr id="1" name=""/>
@@ -6074,50 +5776,7 @@
       <p:grpSpPr/>
       <p:sp>
         <p:nvSpPr>
-          <p:cNvPr id="2" name="Rectangle 1"/>
-          <p:cNvSpPr/>
-          <p:nvPr/>
-        </p:nvSpPr>
-        <p:spPr>
-          <a:xfrm>
-            <a:off x="0" y="0"/>
-            <a:ext cx="12191695" cy="6858000"/>
-          </a:xfrm>
-          <a:prstGeom prst="rect">
-            <a:avLst/>
-          </a:prstGeom>
-          <a:solidFill>
-            <a:srgbClr val="FCFAF2"/>
-          </a:solidFill>
-          <a:ln>
-            <a:noFill/>
-          </a:ln>
-        </p:spPr>
-        <p:style>
-          <a:lnRef idx="1">
-            <a:schemeClr val="accent1"/>
-          </a:lnRef>
-          <a:fillRef idx="3">
-            <a:schemeClr val="accent1"/>
-          </a:fillRef>
-          <a:effectRef idx="2">
-            <a:schemeClr val="accent1"/>
-          </a:effectRef>
-          <a:fontRef idx="minor">
-            <a:schemeClr val="lt1"/>
-          </a:fontRef>
-        </p:style>
-        <p:txBody>
-          <a:bodyPr rtlCol="0" anchor="ctr"/>
-          <a:lstStyle/>
-          <a:p>
-            <a:pPr algn="ctr"/>
-          </a:p>
-        </p:txBody>
-      </p:sp>
-      <p:sp>
-        <p:nvSpPr>
-          <p:cNvPr id="3" name="TextBox 2"/>
+          <p:cNvPr id="2" name="TextBox 1"/>
           <p:cNvSpPr txBox="1"/>
           <p:nvPr/>
         </p:nvSpPr>
@@ -6137,15 +5796,13 @@
           </a:bodyPr>
           <a:lstStyle/>
           <a:p>
-            <a:pPr>
-              <a:defRPr sz="2800" b="1">
+            <a:r>
+              <a:rPr sz="2800" b="1">
                 <a:solidFill>
                   <a:srgbClr val="927005"/>
                 </a:solidFill>
                 <a:latin typeface="Arial"/>
-              </a:defRPr>
-            </a:pPr>
-            <a:r>
+              </a:rPr>
               <a:t>INDUS BRAIN AI: Solution Overview</a:t>
             </a:r>
           </a:p>
@@ -6153,7 +5810,7 @@
       </p:sp>
       <p:sp>
         <p:nvSpPr>
-          <p:cNvPr id="4" name="TextBox 3"/>
+          <p:cNvPr id="3" name="TextBox 2"/>
           <p:cNvSpPr txBox="1"/>
           <p:nvPr/>
         </p:nvSpPr>
@@ -6173,22 +5830,21 @@
           </a:bodyPr>
           <a:lstStyle/>
           <a:p>
-            <a:pPr>
-              <a:defRPr sz="1600" b="1">
+            <a:r>
+              <a:rPr sz="1600" b="1">
                 <a:solidFill>
                   <a:srgbClr val="927005"/>
                 </a:solidFill>
                 <a:latin typeface="Arial"/>
-              </a:defRPr>
-            </a:pPr>
-            <a:r>
+              </a:rPr>
               <a:t>✔  Executive Command Center Dashboard: </a:t>
             </a:r>
             <a:r>
-              <a:rPr b="0">
+              <a:rPr sz="1600" b="0">
                 <a:solidFill>
                   <a:srgbClr val="1E293B"/>
                 </a:solidFill>
+                <a:latin typeface="Arial"/>
               </a:rPr>
               <a:t>Renders instant Plant Health scores, compliance gaps, downtime risks, and incident lists for high-level management oversight.</a:t>
             </a:r>
@@ -6198,21 +5854,22 @@
               <a:spcBef>
                 <a:spcPts val="1400"/>
               </a:spcBef>
-              <a:defRPr sz="1600" b="1">
+            </a:pPr>
+            <a:r>
+              <a:rPr sz="1600" b="1">
                 <a:solidFill>
                   <a:srgbClr val="927005"/>
                 </a:solidFill>
                 <a:latin typeface="Arial"/>
-              </a:defRPr>
-            </a:pPr>
-            <a:r>
+              </a:rPr>
               <a:t>✔  Grounded Citation-Based Chat: </a:t>
             </a:r>
             <a:r>
-              <a:rPr b="0">
+              <a:rPr sz="1600" b="0">
                 <a:solidFill>
                   <a:srgbClr val="1E293B"/>
                 </a:solidFill>
+                <a:latin typeface="Arial"/>
               </a:rPr>
               <a:t>Retrieves safety regulations, equipment procedures, and records, displaying the exact source filename and page numbers to prevent AI hallucination.</a:t>
             </a:r>
@@ -6222,21 +5879,22 @@
               <a:spcBef>
                 <a:spcPts val="1400"/>
               </a:spcBef>
-              <a:defRPr sz="1600" b="1">
+            </a:pPr>
+            <a:r>
+              <a:rPr sz="1600" b="1">
                 <a:solidFill>
                   <a:srgbClr val="927005"/>
                 </a:solidFill>
                 <a:latin typeface="Arial"/>
-              </a:defRPr>
-            </a:pPr>
-            <a:r>
+              </a:rPr>
               <a:t>✔  Relational Knowledge Graph Map: </a:t>
             </a:r>
             <a:r>
-              <a:rPr b="0">
+              <a:rPr sz="1600" b="0">
                 <a:solidFill>
                   <a:srgbClr val="1E293B"/>
                 </a:solidFill>
+                <a:latin typeface="Arial"/>
               </a:rPr>
               <a:t>Visualizes connections across assets, maintenance logs, and audit codes on a live interactive physics-directed graph.</a:t>
             </a:r>
@@ -6246,21 +5904,22 @@
               <a:spcBef>
                 <a:spcPts val="1400"/>
               </a:spcBef>
-              <a:defRPr sz="1600" b="1">
+            </a:pPr>
+            <a:r>
+              <a:rPr sz="1600" b="1">
                 <a:solidFill>
                   <a:srgbClr val="927005"/>
                 </a:solidFill>
                 <a:latin typeface="Arial"/>
-              </a:defRPr>
-            </a:pPr>
-            <a:r>
+              </a:rPr>
               <a:t>✔  Automated Compliance &amp; RCA Engine: </a:t>
             </a:r>
             <a:r>
-              <a:rPr b="0">
+              <a:rPr sz="1600" b="0">
                 <a:solidFill>
                   <a:srgbClr val="1E293B"/>
                 </a:solidFill>
+                <a:latin typeface="Arial"/>
               </a:rPr>
               <a:t>Extracts recurring breakdown root causes, flags regulatory gaps, and recalibrates safety compliance scores via corrective task checklists.</a:t>
             </a:r>
@@ -6278,6 +5937,14 @@
 <file path=ppt/slides/slide5.xml><?xml version="1.0" encoding="utf-8"?>
 <p:sld xmlns:a="http://schemas.openxmlformats.org/drawingml/2006/main" xmlns:p="http://schemas.openxmlformats.org/presentationml/2006/main" xmlns:r="http://schemas.openxmlformats.org/officeDocument/2006/relationships">
   <p:cSld>
+    <p:bg>
+      <p:bgPr>
+        <a:solidFill>
+          <a:srgbClr val="FCFAF2"/>
+        </a:solidFill>
+        <a:effectLst/>
+      </p:bgPr>
+    </p:bg>
     <p:spTree>
       <p:nvGrpSpPr>
         <p:cNvPr id="1" name=""/>
@@ -6287,50 +5954,7 @@
       <p:grpSpPr/>
       <p:sp>
         <p:nvSpPr>
-          <p:cNvPr id="2" name="Rectangle 1"/>
-          <p:cNvSpPr/>
-          <p:nvPr/>
-        </p:nvSpPr>
-        <p:spPr>
-          <a:xfrm>
-            <a:off x="0" y="0"/>
-            <a:ext cx="12191695" cy="6858000"/>
-          </a:xfrm>
-          <a:prstGeom prst="rect">
-            <a:avLst/>
-          </a:prstGeom>
-          <a:solidFill>
-            <a:srgbClr val="FCFAF2"/>
-          </a:solidFill>
-          <a:ln>
-            <a:noFill/>
-          </a:ln>
-        </p:spPr>
-        <p:style>
-          <a:lnRef idx="1">
-            <a:schemeClr val="accent1"/>
-          </a:lnRef>
-          <a:fillRef idx="3">
-            <a:schemeClr val="accent1"/>
-          </a:fillRef>
-          <a:effectRef idx="2">
-            <a:schemeClr val="accent1"/>
-          </a:effectRef>
-          <a:fontRef idx="minor">
-            <a:schemeClr val="lt1"/>
-          </a:fontRef>
-        </p:style>
-        <p:txBody>
-          <a:bodyPr rtlCol="0" anchor="ctr"/>
-          <a:lstStyle/>
-          <a:p>
-            <a:pPr algn="ctr"/>
-          </a:p>
-        </p:txBody>
-      </p:sp>
-      <p:sp>
-        <p:nvSpPr>
-          <p:cNvPr id="3" name="TextBox 2"/>
+          <p:cNvPr id="2" name="TextBox 1"/>
           <p:cNvSpPr txBox="1"/>
           <p:nvPr/>
         </p:nvSpPr>
@@ -6350,15 +5974,13 @@
           </a:bodyPr>
           <a:lstStyle/>
           <a:p>
-            <a:pPr>
-              <a:defRPr sz="2800" b="1">
+            <a:r>
+              <a:rPr sz="2800" b="1">
                 <a:solidFill>
                   <a:srgbClr val="927005"/>
                 </a:solidFill>
                 <a:latin typeface="Arial"/>
-              </a:defRPr>
-            </a:pPr>
-            <a:r>
+              </a:rPr>
               <a:t>System Architecture &amp; Pipeline Integration</a:t>
             </a:r>
           </a:p>
@@ -6366,7 +5988,7 @@
       </p:sp>
       <p:sp>
         <p:nvSpPr>
-          <p:cNvPr id="4" name="TextBox 3"/>
+          <p:cNvPr id="3" name="TextBox 2"/>
           <p:cNvSpPr txBox="1"/>
           <p:nvPr/>
         </p:nvSpPr>
@@ -6386,21 +6008,21 @@
           </a:bodyPr>
           <a:lstStyle/>
           <a:p>
-            <a:pPr>
-              <a:defRPr sz="1400" b="1">
+            <a:r>
+              <a:rPr sz="1400" b="1">
                 <a:solidFill>
                   <a:srgbClr val="927005"/>
                 </a:solidFill>
-              </a:defRPr>
-            </a:pPr>
-            <a:r>
+                <a:latin typeface="Arial"/>
+              </a:rPr>
               <a:t>• Multi-Format Ingestion Engine: </a:t>
             </a:r>
             <a:r>
-              <a:rPr b="0">
+              <a:rPr sz="1400" b="0">
                 <a:solidFill>
                   <a:srgbClr val="1E293B"/>
                 </a:solidFill>
+                <a:latin typeface="Arial"/>
               </a:rPr>
               <a:t>Ingests PDFs, CSVs, and scanned files, running simulated OCR pipelines to compile clean text layers.</a:t>
             </a:r>
@@ -6410,20 +6032,22 @@
               <a:spcBef>
                 <a:spcPts val="1200"/>
               </a:spcBef>
-              <a:defRPr sz="1400" b="1">
+            </a:pPr>
+            <a:r>
+              <a:rPr sz="1400" b="1">
                 <a:solidFill>
                   <a:srgbClr val="927005"/>
                 </a:solidFill>
-              </a:defRPr>
-            </a:pPr>
-            <a:r>
+                <a:latin typeface="Arial"/>
+              </a:rPr>
               <a:t>• NLP NER &amp; Relational Mapper: </a:t>
             </a:r>
             <a:r>
-              <a:rPr b="0">
+              <a:rPr sz="1400" b="0">
                 <a:solidFill>
                   <a:srgbClr val="1E293B"/>
                 </a:solidFill>
+                <a:latin typeface="Arial"/>
               </a:rPr>
               <a:t>Scans text chunks to extract equipment codes, failure modes, regulations, and verb-level relationships.</a:t>
             </a:r>
@@ -6433,20 +6057,22 @@
               <a:spcBef>
                 <a:spcPts val="1200"/>
               </a:spcBef>
-              <a:defRPr sz="1400" b="1">
+            </a:pPr>
+            <a:r>
+              <a:rPr sz="1400" b="1">
                 <a:solidFill>
                   <a:srgbClr val="927005"/>
                 </a:solidFill>
-              </a:defRPr>
-            </a:pPr>
-            <a:r>
+                <a:latin typeface="Arial"/>
+              </a:rPr>
               <a:t>• Relational &amp; Graph SQLite DB: </a:t>
             </a:r>
             <a:r>
-              <a:rPr b="0">
+              <a:rPr sz="1400" b="0">
                 <a:solidFill>
                   <a:srgbClr val="1E293B"/>
                 </a:solidFill>
+                <a:latin typeface="Arial"/>
               </a:rPr>
               <a:t>Stores assets, incidents, maintenance events, rules, extracted nodes, and edges inside local relational tables.</a:t>
             </a:r>
@@ -6456,20 +6082,22 @@
               <a:spcBef>
                 <a:spcPts val="1200"/>
               </a:spcBef>
-              <a:defRPr sz="1400" b="1">
+            </a:pPr>
+            <a:r>
+              <a:rPr sz="1400" b="1">
                 <a:solidFill>
                   <a:srgbClr val="927005"/>
                 </a:solidFill>
-              </a:defRPr>
-            </a:pPr>
-            <a:r>
+                <a:latin typeface="Arial"/>
+              </a:rPr>
               <a:t>• Offline TF-IDF Search DB: </a:t>
             </a:r>
             <a:r>
-              <a:rPr b="0">
+              <a:rPr sz="1400" b="0">
                 <a:solidFill>
                   <a:srgbClr val="1E293B"/>
                 </a:solidFill>
+                <a:latin typeface="Arial"/>
               </a:rPr>
               <a:t>Implements local word overlap RAG queries, eliminating remote cloud vectors and API dependency.</a:t>
             </a:r>
@@ -6478,7 +6106,7 @@
       </p:sp>
       <p:pic>
         <p:nvPicPr>
-          <p:cNvPr id="5" name="Picture 4" descr="architecture_diagram.png"/>
+          <p:cNvPr id="4" name="Picture 3" descr="architecture_diagram.png"/>
           <p:cNvPicPr>
             <a:picLocks noChangeAspect="1"/>
           </p:cNvPicPr>
@@ -6511,6 +6139,14 @@
 <file path=ppt/slides/slide6.xml><?xml version="1.0" encoding="utf-8"?>
 <p:sld xmlns:a="http://schemas.openxmlformats.org/drawingml/2006/main" xmlns:p="http://schemas.openxmlformats.org/presentationml/2006/main" xmlns:r="http://schemas.openxmlformats.org/officeDocument/2006/relationships">
   <p:cSld>
+    <p:bg>
+      <p:bgPr>
+        <a:solidFill>
+          <a:srgbClr val="FCFAF2"/>
+        </a:solidFill>
+        <a:effectLst/>
+      </p:bgPr>
+    </p:bg>
     <p:spTree>
       <p:nvGrpSpPr>
         <p:cNvPr id="1" name=""/>
@@ -6520,50 +6156,7 @@
       <p:grpSpPr/>
       <p:sp>
         <p:nvSpPr>
-          <p:cNvPr id="2" name="Rectangle 1"/>
-          <p:cNvSpPr/>
-          <p:nvPr/>
-        </p:nvSpPr>
-        <p:spPr>
-          <a:xfrm>
-            <a:off x="0" y="0"/>
-            <a:ext cx="12191695" cy="6858000"/>
-          </a:xfrm>
-          <a:prstGeom prst="rect">
-            <a:avLst/>
-          </a:prstGeom>
-          <a:solidFill>
-            <a:srgbClr val="FCFAF2"/>
-          </a:solidFill>
-          <a:ln>
-            <a:noFill/>
-          </a:ln>
-        </p:spPr>
-        <p:style>
-          <a:lnRef idx="1">
-            <a:schemeClr val="accent1"/>
-          </a:lnRef>
-          <a:fillRef idx="3">
-            <a:schemeClr val="accent1"/>
-          </a:fillRef>
-          <a:effectRef idx="2">
-            <a:schemeClr val="accent1"/>
-          </a:effectRef>
-          <a:fontRef idx="minor">
-            <a:schemeClr val="lt1"/>
-          </a:fontRef>
-        </p:style>
-        <p:txBody>
-          <a:bodyPr rtlCol="0" anchor="ctr"/>
-          <a:lstStyle/>
-          <a:p>
-            <a:pPr algn="ctr"/>
-          </a:p>
-        </p:txBody>
-      </p:sp>
-      <p:sp>
-        <p:nvSpPr>
-          <p:cNvPr id="3" name="TextBox 2"/>
+          <p:cNvPr id="2" name="TextBox 1"/>
           <p:cNvSpPr txBox="1"/>
           <p:nvPr/>
         </p:nvSpPr>
@@ -6583,15 +6176,13 @@
           </a:bodyPr>
           <a:lstStyle/>
           <a:p>
-            <a:pPr>
-              <a:defRPr sz="2800" b="1">
+            <a:r>
+              <a:rPr sz="2800" b="1">
                 <a:solidFill>
                   <a:srgbClr val="927005"/>
                 </a:solidFill>
                 <a:latin typeface="Arial"/>
-              </a:defRPr>
-            </a:pPr>
-            <a:r>
+              </a:rPr>
               <a:t>Knowledge Graph: Connecting Silos</a:t>
             </a:r>
           </a:p>
@@ -6599,7 +6190,7 @@
       </p:sp>
       <p:sp>
         <p:nvSpPr>
-          <p:cNvPr id="4" name="TextBox 3"/>
+          <p:cNvPr id="3" name="TextBox 2"/>
           <p:cNvSpPr txBox="1"/>
           <p:nvPr/>
         </p:nvSpPr>
@@ -6619,21 +6210,21 @@
           </a:bodyPr>
           <a:lstStyle/>
           <a:p>
-            <a:pPr>
-              <a:defRPr sz="1400" b="1">
+            <a:r>
+              <a:rPr sz="1400" b="1">
                 <a:solidFill>
                   <a:srgbClr val="927005"/>
                 </a:solidFill>
-              </a:defRPr>
-            </a:pPr>
-            <a:r>
+                <a:latin typeface="Arial"/>
+              </a:rPr>
               <a:t>• Relationship Networks: </a:t>
             </a:r>
             <a:r>
-              <a:rPr b="0">
+              <a:rPr sz="1400" b="0">
                 <a:solidFill>
                   <a:srgbClr val="1E293B"/>
                 </a:solidFill>
+                <a:latin typeface="Arial"/>
               </a:rPr>
               <a:t>Assets are linked to procedures (SOPs), safety findings, and maintenance events. This builds logic paths beyond search.</a:t>
             </a:r>
@@ -6641,22 +6232,24 @@
           <a:p>
             <a:pPr>
               <a:spcBef>
-                <a:spcPts val="1400"/>
+                <a:spcPts val="1200"/>
               </a:spcBef>
-              <a:defRPr sz="1400" b="1">
+            </a:pPr>
+            <a:r>
+              <a:rPr sz="1400" b="1">
                 <a:solidFill>
                   <a:srgbClr val="927005"/>
                 </a:solidFill>
-              </a:defRPr>
-            </a:pPr>
-            <a:r>
+                <a:latin typeface="Arial"/>
+              </a:rPr>
               <a:t>• Drill-Down Graph Refocus: </a:t>
             </a:r>
             <a:r>
-              <a:rPr b="0">
+              <a:rPr sz="1400" b="0">
                 <a:solidFill>
                   <a:srgbClr val="1E293B"/>
                 </a:solidFill>
+                <a:latin typeface="Arial"/>
               </a:rPr>
               <a:t>Double-clicking any node triggers an API drill-down to isolate and map neighbor connections.</a:t>
             </a:r>
@@ -6664,22 +6257,24 @@
           <a:p>
             <a:pPr>
               <a:spcBef>
-                <a:spcPts val="1400"/>
+                <a:spcPts val="1200"/>
               </a:spcBef>
-              <a:defRPr sz="1400" b="1">
+            </a:pPr>
+            <a:r>
+              <a:rPr sz="1400" b="1">
                 <a:solidFill>
                   <a:srgbClr val="927005"/>
                 </a:solidFill>
-              </a:defRPr>
-            </a:pPr>
-            <a:r>
+                <a:latin typeface="Arial"/>
+              </a:rPr>
               <a:t>• Graph Statistics (Dynamic Seeding): </a:t>
             </a:r>
             <a:r>
-              <a:rPr b="0">
+              <a:rPr sz="1400" b="0">
                 <a:solidFill>
                   <a:srgbClr val="1E293B"/>
                 </a:solidFill>
+                <a:latin typeface="Arial"/>
               </a:rPr>
               <a:t>Contains 226 unique nodes and 351 active relationships, achieving a dense network ratio of 1.55 edges per node.</a:t>
             </a:r>
@@ -6688,7 +6283,7 @@
       </p:sp>
       <p:pic>
         <p:nvPicPr>
-          <p:cNvPr id="5" name="Picture 4" descr="graph_view_screenshot.png"/>
+          <p:cNvPr id="4" name="Picture 3" descr="graph_view_screenshot.png"/>
           <p:cNvPicPr>
             <a:picLocks noChangeAspect="1"/>
           </p:cNvPicPr>
@@ -6721,6 +6316,14 @@
 <file path=ppt/slides/slide7.xml><?xml version="1.0" encoding="utf-8"?>
 <p:sld xmlns:a="http://schemas.openxmlformats.org/drawingml/2006/main" xmlns:p="http://schemas.openxmlformats.org/presentationml/2006/main" xmlns:r="http://schemas.openxmlformats.org/officeDocument/2006/relationships">
   <p:cSld>
+    <p:bg>
+      <p:bgPr>
+        <a:solidFill>
+          <a:srgbClr val="FCFAF2"/>
+        </a:solidFill>
+        <a:effectLst/>
+      </p:bgPr>
+    </p:bg>
     <p:spTree>
       <p:nvGrpSpPr>
         <p:cNvPr id="1" name=""/>
@@ -6730,50 +6333,7 @@
       <p:grpSpPr/>
       <p:sp>
         <p:nvSpPr>
-          <p:cNvPr id="2" name="Rectangle 1"/>
-          <p:cNvSpPr/>
-          <p:nvPr/>
-        </p:nvSpPr>
-        <p:spPr>
-          <a:xfrm>
-            <a:off x="0" y="0"/>
-            <a:ext cx="12191695" cy="6858000"/>
-          </a:xfrm>
-          <a:prstGeom prst="rect">
-            <a:avLst/>
-          </a:prstGeom>
-          <a:solidFill>
-            <a:srgbClr val="FCFAF2"/>
-          </a:solidFill>
-          <a:ln>
-            <a:noFill/>
-          </a:ln>
-        </p:spPr>
-        <p:style>
-          <a:lnRef idx="1">
-            <a:schemeClr val="accent1"/>
-          </a:lnRef>
-          <a:fillRef idx="3">
-            <a:schemeClr val="accent1"/>
-          </a:fillRef>
-          <a:effectRef idx="2">
-            <a:schemeClr val="accent1"/>
-          </a:effectRef>
-          <a:fontRef idx="minor">
-            <a:schemeClr val="lt1"/>
-          </a:fontRef>
-        </p:style>
-        <p:txBody>
-          <a:bodyPr rtlCol="0" anchor="ctr"/>
-          <a:lstStyle/>
-          <a:p>
-            <a:pPr algn="ctr"/>
-          </a:p>
-        </p:txBody>
-      </p:sp>
-      <p:sp>
-        <p:nvSpPr>
-          <p:cNvPr id="3" name="TextBox 2"/>
+          <p:cNvPr id="2" name="TextBox 1"/>
           <p:cNvSpPr txBox="1"/>
           <p:nvPr/>
         </p:nvSpPr>
@@ -6793,15 +6353,13 @@
           </a:bodyPr>
           <a:lstStyle/>
           <a:p>
-            <a:pPr>
-              <a:defRPr sz="2800" b="1">
+            <a:r>
+              <a:rPr sz="2800" b="1">
                 <a:solidFill>
                   <a:srgbClr val="927005"/>
                 </a:solidFill>
                 <a:latin typeface="Arial"/>
-              </a:defRPr>
-            </a:pPr>
-            <a:r>
+              </a:rPr>
               <a:t>Grounded Copilot RAG &amp; Gemini Key Rotation</a:t>
             </a:r>
           </a:p>
@@ -6809,7 +6367,7 @@
       </p:sp>
       <p:sp>
         <p:nvSpPr>
-          <p:cNvPr id="4" name="TextBox 3"/>
+          <p:cNvPr id="3" name="TextBox 2"/>
           <p:cNvSpPr txBox="1"/>
           <p:nvPr/>
         </p:nvSpPr>
@@ -6829,21 +6387,21 @@
           </a:bodyPr>
           <a:lstStyle/>
           <a:p>
-            <a:pPr>
-              <a:defRPr sz="1400" b="1">
+            <a:r>
+              <a:rPr sz="1400" b="1">
                 <a:solidFill>
                   <a:srgbClr val="927005"/>
                 </a:solidFill>
-              </a:defRPr>
-            </a:pPr>
-            <a:r>
+                <a:latin typeface="Arial"/>
+              </a:rPr>
               <a:t>• 100% Citation Grounding: </a:t>
             </a:r>
             <a:r>
-              <a:rPr b="0">
+              <a:rPr sz="1400" b="0">
                 <a:solidFill>
                   <a:srgbClr val="1E293B"/>
                 </a:solidFill>
+                <a:latin typeface="Arial"/>
               </a:rPr>
               <a:t>Retrieves overlapping vectors and tags to answer diagnostic prompts. Every answer details the file source, page index, and confidence score.</a:t>
             </a:r>
@@ -6851,22 +6409,24 @@
           <a:p>
             <a:pPr>
               <a:spcBef>
-                <a:spcPts val="1400"/>
+                <a:spcPts val="1200"/>
               </a:spcBef>
-              <a:defRPr sz="1400" b="1">
+            </a:pPr>
+            <a:r>
+              <a:rPr sz="1400" b="1">
                 <a:solidFill>
                   <a:srgbClr val="927005"/>
                 </a:solidFill>
-              </a:defRPr>
-            </a:pPr>
-            <a:r>
+                <a:latin typeface="Arial"/>
+              </a:rPr>
               <a:t>• Rotated API Key Wrapper: </a:t>
             </a:r>
             <a:r>
-              <a:rPr b="0">
+              <a:rPr sz="1400" b="0">
                 <a:solidFill>
                   <a:srgbClr val="1E293B"/>
                 </a:solidFill>
+                <a:latin typeface="Arial"/>
               </a:rPr>
               <a:t>Rotates across three configured Gemini keys to handle rate limits and request throttle errors.</a:t>
             </a:r>
@@ -6874,22 +6434,24 @@
           <a:p>
             <a:pPr>
               <a:spcBef>
-                <a:spcPts val="1400"/>
+                <a:spcPts val="1200"/>
               </a:spcBef>
-              <a:defRPr sz="1400" b="1">
+            </a:pPr>
+            <a:r>
+              <a:rPr sz="1400" b="1">
                 <a:solidFill>
                   <a:srgbClr val="927005"/>
                 </a:solidFill>
-              </a:defRPr>
-            </a:pPr>
-            <a:r>
+                <a:latin typeface="Arial"/>
+              </a:rPr>
               <a:t>• Robust Local Fallback Engine: </a:t>
             </a:r>
             <a:r>
-              <a:rPr b="0">
+              <a:rPr sz="1400" b="0">
                 <a:solidFill>
                   <a:srgbClr val="1E293B"/>
                 </a:solidFill>
+                <a:latin typeface="Arial"/>
               </a:rPr>
               <a:t>If keys are missing, the system uses local TF-IDF matching to output citation snippets and answer mock templates offline.</a:t>
             </a:r>
@@ -6898,7 +6460,7 @@
       </p:sp>
       <p:pic>
         <p:nvPicPr>
-          <p:cNvPr id="5" name="Picture 4" descr="copilot_chat_screenshot.png"/>
+          <p:cNvPr id="4" name="Picture 3" descr="copilot_chat_screenshot.png"/>
           <p:cNvPicPr>
             <a:picLocks noChangeAspect="1"/>
           </p:cNvPicPr>
@@ -6931,6 +6493,14 @@
 <file path=ppt/slides/slide8.xml><?xml version="1.0" encoding="utf-8"?>
 <p:sld xmlns:a="http://schemas.openxmlformats.org/drawingml/2006/main" xmlns:p="http://schemas.openxmlformats.org/presentationml/2006/main" xmlns:r="http://schemas.openxmlformats.org/officeDocument/2006/relationships">
   <p:cSld>
+    <p:bg>
+      <p:bgPr>
+        <a:solidFill>
+          <a:srgbClr val="FCFAF2"/>
+        </a:solidFill>
+        <a:effectLst/>
+      </p:bgPr>
+    </p:bg>
     <p:spTree>
       <p:nvGrpSpPr>
         <p:cNvPr id="1" name=""/>
@@ -6940,50 +6510,7 @@
       <p:grpSpPr/>
       <p:sp>
         <p:nvSpPr>
-          <p:cNvPr id="2" name="Rectangle 1"/>
-          <p:cNvSpPr/>
-          <p:nvPr/>
-        </p:nvSpPr>
-        <p:spPr>
-          <a:xfrm>
-            <a:off x="0" y="0"/>
-            <a:ext cx="12191695" cy="6858000"/>
-          </a:xfrm>
-          <a:prstGeom prst="rect">
-            <a:avLst/>
-          </a:prstGeom>
-          <a:solidFill>
-            <a:srgbClr val="FCFAF2"/>
-          </a:solidFill>
-          <a:ln>
-            <a:noFill/>
-          </a:ln>
-        </p:spPr>
-        <p:style>
-          <a:lnRef idx="1">
-            <a:schemeClr val="accent1"/>
-          </a:lnRef>
-          <a:fillRef idx="3">
-            <a:schemeClr val="accent1"/>
-          </a:fillRef>
-          <a:effectRef idx="2">
-            <a:schemeClr val="accent1"/>
-          </a:effectRef>
-          <a:fontRef idx="minor">
-            <a:schemeClr val="lt1"/>
-          </a:fontRef>
-        </p:style>
-        <p:txBody>
-          <a:bodyPr rtlCol="0" anchor="ctr"/>
-          <a:lstStyle/>
-          <a:p>
-            <a:pPr algn="ctr"/>
-          </a:p>
-        </p:txBody>
-      </p:sp>
-      <p:sp>
-        <p:nvSpPr>
-          <p:cNvPr id="3" name="TextBox 2"/>
+          <p:cNvPr id="2" name="TextBox 1"/>
           <p:cNvSpPr txBox="1"/>
           <p:nvPr/>
         </p:nvSpPr>
@@ -7003,15 +6530,13 @@
           </a:bodyPr>
           <a:lstStyle/>
           <a:p>
-            <a:pPr>
-              <a:defRPr sz="2800" b="1">
+            <a:r>
+              <a:rPr sz="2800" b="1">
                 <a:solidFill>
                   <a:srgbClr val="927005"/>
                 </a:solidFill>
                 <a:latin typeface="Arial"/>
-              </a:defRPr>
-            </a:pPr>
-            <a:r>
+              </a:rPr>
               <a:t>Asset Digital Twin &amp; Root Cause Analysis</a:t>
             </a:r>
           </a:p>
@@ -7019,7 +6544,7 @@
       </p:sp>
       <p:sp>
         <p:nvSpPr>
-          <p:cNvPr id="4" name="TextBox 3"/>
+          <p:cNvPr id="3" name="TextBox 2"/>
           <p:cNvSpPr txBox="1"/>
           <p:nvPr/>
         </p:nvSpPr>
@@ -7039,21 +6564,21 @@
           </a:bodyPr>
           <a:lstStyle/>
           <a:p>
-            <a:pPr>
-              <a:defRPr sz="1400" b="1">
+            <a:r>
+              <a:rPr sz="1400" b="1">
                 <a:solidFill>
                   <a:srgbClr val="927005"/>
                 </a:solidFill>
-              </a:defRPr>
-            </a:pPr>
-            <a:r>
+                <a:latin typeface="Arial"/>
+              </a:rPr>
               <a:t>• Comprehensive Asset Twin Profile: </a:t>
             </a:r>
             <a:r>
-              <a:rPr b="0">
+              <a:rPr sz="1400" b="0">
                 <a:solidFill>
                   <a:srgbClr val="1E293B"/>
                 </a:solidFill>
+                <a:latin typeface="Arial"/>
               </a:rPr>
               <a:t>Consolidates equipment logs, location, risk rankings, and adjacent graph nodes inside one digital interface.</a:t>
             </a:r>
@@ -7061,22 +6586,24 @@
           <a:p>
             <a:pPr>
               <a:spcBef>
-                <a:spcPts val="1400"/>
+                <a:spcPts val="1200"/>
               </a:spcBef>
-              <a:defRPr sz="1400" b="1">
+            </a:pPr>
+            <a:r>
+              <a:rPr sz="1400" b="1">
                 <a:solidFill>
                   <a:srgbClr val="927005"/>
                 </a:solidFill>
-              </a:defRPr>
-            </a:pPr>
-            <a:r>
+                <a:latin typeface="Arial"/>
+              </a:rPr>
               <a:t>• Maintenance History Ledger: </a:t>
             </a:r>
             <a:r>
-              <a:rPr b="0">
+              <a:rPr sz="1400" b="0">
                 <a:solidFill>
                   <a:srgbClr val="1E293B"/>
                 </a:solidFill>
+                <a:latin typeface="Arial"/>
               </a:rPr>
               <a:t>Maps historical repair costs and durations, tracking anomalies and repair frequencies.</a:t>
             </a:r>
@@ -7084,22 +6611,24 @@
           <a:p>
             <a:pPr>
               <a:spcBef>
-                <a:spcPts val="1400"/>
+                <a:spcPts val="1200"/>
               </a:spcBef>
-              <a:defRPr sz="1400" b="1">
+            </a:pPr>
+            <a:r>
+              <a:rPr sz="1400" b="1">
                 <a:solidFill>
                   <a:srgbClr val="927005"/>
                 </a:solidFill>
-              </a:defRPr>
-            </a:pPr>
-            <a:r>
+                <a:latin typeface="Arial"/>
+              </a:rPr>
               <a:t>• RCA Evidence Audit Trail: </a:t>
             </a:r>
             <a:r>
-              <a:rPr b="0">
+              <a:rPr sz="1400" b="0">
                 <a:solidFill>
                   <a:srgbClr val="1E293B"/>
                 </a:solidFill>
+                <a:latin typeface="Arial"/>
               </a:rPr>
               <a:t>Retrieves safety logs and inspections to reconstruct failure causes (e.g. pressure spikes), displaying verbatim text citations.</a:t>
             </a:r>
@@ -7108,7 +6637,7 @@
       </p:sp>
       <p:pic>
         <p:nvPicPr>
-          <p:cNvPr id="5" name="Picture 4" descr="digital_twin_screenshot.png"/>
+          <p:cNvPr id="4" name="Picture 3" descr="digital_twin_screenshot.png"/>
           <p:cNvPicPr>
             <a:picLocks noChangeAspect="1"/>
           </p:cNvPicPr>
@@ -7141,6 +6670,14 @@
 <file path=ppt/slides/slide9.xml><?xml version="1.0" encoding="utf-8"?>
 <p:sld xmlns:a="http://schemas.openxmlformats.org/drawingml/2006/main" xmlns:p="http://schemas.openxmlformats.org/presentationml/2006/main" xmlns:r="http://schemas.openxmlformats.org/officeDocument/2006/relationships">
   <p:cSld>
+    <p:bg>
+      <p:bgPr>
+        <a:solidFill>
+          <a:srgbClr val="FCFAF2"/>
+        </a:solidFill>
+        <a:effectLst/>
+      </p:bgPr>
+    </p:bg>
     <p:spTree>
       <p:nvGrpSpPr>
         <p:cNvPr id="1" name=""/>
@@ -7150,50 +6687,7 @@
       <p:grpSpPr/>
       <p:sp>
         <p:nvSpPr>
-          <p:cNvPr id="2" name="Rectangle 1"/>
-          <p:cNvSpPr/>
-          <p:nvPr/>
-        </p:nvSpPr>
-        <p:spPr>
-          <a:xfrm>
-            <a:off x="0" y="0"/>
-            <a:ext cx="12191695" cy="6858000"/>
-          </a:xfrm>
-          <a:prstGeom prst="rect">
-            <a:avLst/>
-          </a:prstGeom>
-          <a:solidFill>
-            <a:srgbClr val="FCFAF2"/>
-          </a:solidFill>
-          <a:ln>
-            <a:noFill/>
-          </a:ln>
-        </p:spPr>
-        <p:style>
-          <a:lnRef idx="1">
-            <a:schemeClr val="accent1"/>
-          </a:lnRef>
-          <a:fillRef idx="3">
-            <a:schemeClr val="accent1"/>
-          </a:fillRef>
-          <a:effectRef idx="2">
-            <a:schemeClr val="accent1"/>
-          </a:effectRef>
-          <a:fontRef idx="minor">
-            <a:schemeClr val="lt1"/>
-          </a:fontRef>
-        </p:style>
-        <p:txBody>
-          <a:bodyPr rtlCol="0" anchor="ctr"/>
-          <a:lstStyle/>
-          <a:p>
-            <a:pPr algn="ctr"/>
-          </a:p>
-        </p:txBody>
-      </p:sp>
-      <p:sp>
-        <p:nvSpPr>
-          <p:cNvPr id="3" name="TextBox 2"/>
+          <p:cNvPr id="2" name="TextBox 1"/>
           <p:cNvSpPr txBox="1"/>
           <p:nvPr/>
         </p:nvSpPr>
@@ -7213,15 +6707,13 @@
           </a:bodyPr>
           <a:lstStyle/>
           <a:p>
-            <a:pPr>
-              <a:defRPr sz="2800" b="1">
+            <a:r>
+              <a:rPr sz="2800" b="1">
                 <a:solidFill>
                   <a:srgbClr val="927005"/>
                 </a:solidFill>
                 <a:latin typeface="Arial"/>
-              </a:defRPr>
-            </a:pPr>
-            <a:r>
+              </a:rPr>
               <a:t>Compliance Engine &amp; Safety Rules Audit</a:t>
             </a:r>
           </a:p>
@@ -7229,7 +6721,7 @@
       </p:sp>
       <p:sp>
         <p:nvSpPr>
-          <p:cNvPr id="4" name="TextBox 3"/>
+          <p:cNvPr id="3" name="TextBox 2"/>
           <p:cNvSpPr txBox="1"/>
           <p:nvPr/>
         </p:nvSpPr>
@@ -7249,21 +6741,21 @@
           </a:bodyPr>
           <a:lstStyle/>
           <a:p>
-            <a:pPr>
-              <a:defRPr sz="1400" b="1">
+            <a:r>
+              <a:rPr sz="1400" b="1">
                 <a:solidFill>
                   <a:srgbClr val="927005"/>
                 </a:solidFill>
-              </a:defRPr>
-            </a:pPr>
-            <a:r>
+                <a:latin typeface="Arial"/>
+              </a:rPr>
               <a:t>• Automated Regulation Check: </a:t>
             </a:r>
             <a:r>
-              <a:rPr b="0">
+              <a:rPr sz="1400" b="0">
                 <a:solidFill>
                   <a:srgbClr val="1E293B"/>
                 </a:solidFill>
+                <a:latin typeface="Arial"/>
               </a:rPr>
               <a:t>Scans ingested manuals against safety rules: pressure vessel certifications, thickness tests, and operator licenses.</a:t>
             </a:r>
@@ -7271,22 +6763,24 @@
           <a:p>
             <a:pPr>
               <a:spcBef>
-                <a:spcPts val="1400"/>
+                <a:spcPts val="1200"/>
               </a:spcBef>
-              <a:defRPr sz="1400" b="1">
+            </a:pPr>
+            <a:r>
+              <a:rPr sz="1400" b="1">
                 <a:solidFill>
                   <a:srgbClr val="927005"/>
                 </a:solidFill>
-              </a:defRPr>
-            </a:pPr>
-            <a:r>
+                <a:latin typeface="Arial"/>
+              </a:rPr>
               <a:t>• Interactive Corrective Action Checklists: </a:t>
             </a:r>
             <a:r>
-              <a:rPr b="0">
+              <a:rPr sz="1400" b="0">
                 <a:solidFill>
                   <a:srgbClr val="1E293B"/>
                 </a:solidFill>
+                <a:latin typeface="Arial"/>
               </a:rPr>
               <a:t>Maps compliance gaps to tasks and safety owners, outlining specific deadlines.</a:t>
             </a:r>
@@ -7294,22 +6788,24 @@
           <a:p>
             <a:pPr>
               <a:spcBef>
-                <a:spcPts val="1400"/>
+                <a:spcPts val="1200"/>
               </a:spcBef>
-              <a:defRPr sz="1400" b="1">
+            </a:pPr>
+            <a:r>
+              <a:rPr sz="1400" b="1">
                 <a:solidFill>
                   <a:srgbClr val="927005"/>
                 </a:solidFill>
-              </a:defRPr>
-            </a:pPr>
-            <a:r>
+                <a:latin typeface="Arial"/>
+              </a:rPr>
               <a:t>• Dynamic Compliance Score Recalibration: </a:t>
             </a:r>
             <a:r>
-              <a:rPr b="0">
+              <a:rPr sz="1400" b="0">
                 <a:solidFill>
                   <a:srgbClr val="1E293B"/>
                 </a:solidFill>
+                <a:latin typeface="Arial"/>
               </a:rPr>
               <a:t>Completing checklist actions changes gap statuses to compliant, dynamically updating the safety score from 64% to 100% in real-time.</a:t>
             </a:r>
@@ -7318,7 +6814,7 @@
       </p:sp>
       <p:pic>
         <p:nvPicPr>
-          <p:cNvPr id="5" name="Picture 4" descr="compliance_dashboard_screenshot.png"/>
+          <p:cNvPr id="4" name="Picture 3" descr="compliance_dashboard_screenshot.png"/>
           <p:cNvPicPr>
             <a:picLocks noChangeAspect="1"/>
           </p:cNvPicPr>

</xml_diff>